<commit_message>
Working on CSS and XSLT.
</commit_message>
<xml_diff>
--- a/documentation/Refactorización XLST.pptx
+++ b/documentation/Refactorización XLST.pptx
@@ -8,6 +8,7 @@
     <p:sldId id="257" r:id="rId2"/>
     <p:sldId id="258" r:id="rId3"/>
     <p:sldId id="259" r:id="rId4"/>
+    <p:sldId id="260" r:id="rId5"/>
   </p:sldIdLst>
   <p:sldSz cx="12192000" cy="6858000"/>
   <p:notesSz cx="6797675" cy="9872663"/>
@@ -826,7 +827,7 @@
           <a:p>
             <a:fld id="{93065D2E-367D-4F9D-9E24-4F44260CE426}" type="datetimeFigureOut">
               <a:rPr lang="es-ES" smtClean="0"/>
-              <a:t>09/09/2026</a:t>
+              <a:t>12/09/2026</a:t>
             </a:fld>
             <a:endParaRPr lang="es-ES"/>
           </a:p>
@@ -1024,7 +1025,7 @@
           <a:p>
             <a:fld id="{93065D2E-367D-4F9D-9E24-4F44260CE426}" type="datetimeFigureOut">
               <a:rPr lang="es-ES" smtClean="0"/>
-              <a:t>09/09/2026</a:t>
+              <a:t>12/09/2026</a:t>
             </a:fld>
             <a:endParaRPr lang="es-ES"/>
           </a:p>
@@ -1232,7 +1233,7 @@
           <a:p>
             <a:fld id="{93065D2E-367D-4F9D-9E24-4F44260CE426}" type="datetimeFigureOut">
               <a:rPr lang="es-ES" smtClean="0"/>
-              <a:t>09/09/2026</a:t>
+              <a:t>12/09/2026</a:t>
             </a:fld>
             <a:endParaRPr lang="es-ES"/>
           </a:p>
@@ -1430,7 +1431,7 @@
           <a:p>
             <a:fld id="{93065D2E-367D-4F9D-9E24-4F44260CE426}" type="datetimeFigureOut">
               <a:rPr lang="es-ES" smtClean="0"/>
-              <a:t>09/09/2026</a:t>
+              <a:t>12/09/2026</a:t>
             </a:fld>
             <a:endParaRPr lang="es-ES"/>
           </a:p>
@@ -1705,7 +1706,7 @@
           <a:p>
             <a:fld id="{93065D2E-367D-4F9D-9E24-4F44260CE426}" type="datetimeFigureOut">
               <a:rPr lang="es-ES" smtClean="0"/>
-              <a:t>09/09/2026</a:t>
+              <a:t>12/09/2026</a:t>
             </a:fld>
             <a:endParaRPr lang="es-ES"/>
           </a:p>
@@ -1970,7 +1971,7 @@
           <a:p>
             <a:fld id="{93065D2E-367D-4F9D-9E24-4F44260CE426}" type="datetimeFigureOut">
               <a:rPr lang="es-ES" smtClean="0"/>
-              <a:t>09/09/2026</a:t>
+              <a:t>12/09/2026</a:t>
             </a:fld>
             <a:endParaRPr lang="es-ES"/>
           </a:p>
@@ -2382,7 +2383,7 @@
           <a:p>
             <a:fld id="{93065D2E-367D-4F9D-9E24-4F44260CE426}" type="datetimeFigureOut">
               <a:rPr lang="es-ES" smtClean="0"/>
-              <a:t>09/09/2026</a:t>
+              <a:t>12/09/2026</a:t>
             </a:fld>
             <a:endParaRPr lang="es-ES"/>
           </a:p>
@@ -2523,7 +2524,7 @@
           <a:p>
             <a:fld id="{93065D2E-367D-4F9D-9E24-4F44260CE426}" type="datetimeFigureOut">
               <a:rPr lang="es-ES" smtClean="0"/>
-              <a:t>09/09/2026</a:t>
+              <a:t>12/09/2026</a:t>
             </a:fld>
             <a:endParaRPr lang="es-ES"/>
           </a:p>
@@ -2636,7 +2637,7 @@
           <a:p>
             <a:fld id="{93065D2E-367D-4F9D-9E24-4F44260CE426}" type="datetimeFigureOut">
               <a:rPr lang="es-ES" smtClean="0"/>
-              <a:t>09/09/2026</a:t>
+              <a:t>12/09/2026</a:t>
             </a:fld>
             <a:endParaRPr lang="es-ES"/>
           </a:p>
@@ -2947,7 +2948,7 @@
           <a:p>
             <a:fld id="{93065D2E-367D-4F9D-9E24-4F44260CE426}" type="datetimeFigureOut">
               <a:rPr lang="es-ES" smtClean="0"/>
-              <a:t>09/09/2026</a:t>
+              <a:t>12/09/2026</a:t>
             </a:fld>
             <a:endParaRPr lang="es-ES"/>
           </a:p>
@@ -3235,7 +3236,7 @@
           <a:p>
             <a:fld id="{93065D2E-367D-4F9D-9E24-4F44260CE426}" type="datetimeFigureOut">
               <a:rPr lang="es-ES" smtClean="0"/>
-              <a:t>09/09/2026</a:t>
+              <a:t>12/09/2026</a:t>
             </a:fld>
             <a:endParaRPr lang="es-ES"/>
           </a:p>
@@ -3476,7 +3477,7 @@
           <a:p>
             <a:fld id="{93065D2E-367D-4F9D-9E24-4F44260CE426}" type="datetimeFigureOut">
               <a:rPr lang="es-ES" smtClean="0"/>
-              <a:t>09/09/2026</a:t>
+              <a:t>12/09/2026</a:t>
             </a:fld>
             <a:endParaRPr lang="es-ES"/>
           </a:p>
@@ -10916,6 +10917,82 @@
 </p:sld>
 </file>
 
+<file path=ppt/slides/slide4.xml><?xml version="1.0" encoding="utf-8"?>
+<p:sld xmlns:a="http://schemas.openxmlformats.org/drawingml/2006/main" xmlns:r="http://schemas.openxmlformats.org/officeDocument/2006/relationships" xmlns:p="http://schemas.openxmlformats.org/presentationml/2006/main">
+  <p:cSld>
+    <p:spTree>
+      <p:nvGrpSpPr>
+        <p:cNvPr id="1" name=""/>
+        <p:cNvGrpSpPr/>
+        <p:nvPr/>
+      </p:nvGrpSpPr>
+      <p:grpSpPr>
+        <a:xfrm>
+          <a:off x="0" y="0"/>
+          <a:ext cx="0" cy="0"/>
+          <a:chOff x="0" y="0"/>
+          <a:chExt cx="0" cy="0"/>
+        </a:xfrm>
+      </p:grpSpPr>
+      <p:pic>
+        <p:nvPicPr>
+          <p:cNvPr id="3" name="Imagen 2">
+            <a:extLst>
+              <a:ext uri="{FF2B5EF4-FFF2-40B4-BE49-F238E27FC236}">
+                <a16:creationId xmlns:a16="http://schemas.microsoft.com/office/drawing/2014/main" id="{C67BD650-7DE6-4C6C-A08F-3FF0F345B8E1}"/>
+              </a:ext>
+            </a:extLst>
+          </p:cNvPr>
+          <p:cNvPicPr>
+            <a:picLocks noChangeAspect="1"/>
+          </p:cNvPicPr>
+          <p:nvPr/>
+        </p:nvPicPr>
+        <p:blipFill>
+          <a:blip r:embed="rId2">
+            <a:clrChange>
+              <a:clrFrom>
+                <a:srgbClr val="FFFFFF"/>
+              </a:clrFrom>
+              <a:clrTo>
+                <a:srgbClr val="FFFFFF">
+                  <a:alpha val="0"/>
+                </a:srgbClr>
+              </a:clrTo>
+            </a:clrChange>
+            <a:extLst>
+              <a:ext uri="{28A0092B-C50C-407E-A947-70E740481C1C}">
+                <a14:useLocalDpi xmlns:a14="http://schemas.microsoft.com/office/drawing/2010/main" val="0"/>
+              </a:ext>
+            </a:extLst>
+          </a:blip>
+          <a:stretch>
+            <a:fillRect/>
+          </a:stretch>
+        </p:blipFill>
+        <p:spPr>
+          <a:xfrm flipH="1">
+            <a:off x="3055559" y="1437997"/>
+            <a:ext cx="987517" cy="957731"/>
+          </a:xfrm>
+          <a:prstGeom prst="rect">
+            <a:avLst/>
+          </a:prstGeom>
+        </p:spPr>
+      </p:pic>
+    </p:spTree>
+    <p:extLst>
+      <p:ext uri="{BB962C8B-B14F-4D97-AF65-F5344CB8AC3E}">
+        <p14:creationId xmlns:p14="http://schemas.microsoft.com/office/powerpoint/2010/main" val="1278600191"/>
+      </p:ext>
+    </p:extLst>
+  </p:cSld>
+  <p:clrMapOvr>
+    <a:masterClrMapping/>
+  </p:clrMapOvr>
+</p:sld>
+</file>
+
 <file path=ppt/theme/theme1.xml><?xml version="1.0" encoding="utf-8"?>
 <a:theme xmlns:a="http://schemas.openxmlformats.org/drawingml/2006/main" name="Tema de Office">
   <a:themeElements>

</xml_diff>

<commit_message>
Generic table for any object ready.
</commit_message>
<xml_diff>
--- a/documentation/Refactorización XLST.pptx
+++ b/documentation/Refactorización XLST.pptx
@@ -827,7 +827,7 @@
           <a:p>
             <a:fld id="{93065D2E-367D-4F9D-9E24-4F44260CE426}" type="datetimeFigureOut">
               <a:rPr lang="es-ES" smtClean="0"/>
-              <a:t>12/09/2026</a:t>
+              <a:t>13/09/2026</a:t>
             </a:fld>
             <a:endParaRPr lang="es-ES"/>
           </a:p>
@@ -1025,7 +1025,7 @@
           <a:p>
             <a:fld id="{93065D2E-367D-4F9D-9E24-4F44260CE426}" type="datetimeFigureOut">
               <a:rPr lang="es-ES" smtClean="0"/>
-              <a:t>12/09/2026</a:t>
+              <a:t>13/09/2026</a:t>
             </a:fld>
             <a:endParaRPr lang="es-ES"/>
           </a:p>
@@ -1233,7 +1233,7 @@
           <a:p>
             <a:fld id="{93065D2E-367D-4F9D-9E24-4F44260CE426}" type="datetimeFigureOut">
               <a:rPr lang="es-ES" smtClean="0"/>
-              <a:t>12/09/2026</a:t>
+              <a:t>13/09/2026</a:t>
             </a:fld>
             <a:endParaRPr lang="es-ES"/>
           </a:p>
@@ -1431,7 +1431,7 @@
           <a:p>
             <a:fld id="{93065D2E-367D-4F9D-9E24-4F44260CE426}" type="datetimeFigureOut">
               <a:rPr lang="es-ES" smtClean="0"/>
-              <a:t>12/09/2026</a:t>
+              <a:t>13/09/2026</a:t>
             </a:fld>
             <a:endParaRPr lang="es-ES"/>
           </a:p>
@@ -1706,7 +1706,7 @@
           <a:p>
             <a:fld id="{93065D2E-367D-4F9D-9E24-4F44260CE426}" type="datetimeFigureOut">
               <a:rPr lang="es-ES" smtClean="0"/>
-              <a:t>12/09/2026</a:t>
+              <a:t>13/09/2026</a:t>
             </a:fld>
             <a:endParaRPr lang="es-ES"/>
           </a:p>
@@ -1971,7 +1971,7 @@
           <a:p>
             <a:fld id="{93065D2E-367D-4F9D-9E24-4F44260CE426}" type="datetimeFigureOut">
               <a:rPr lang="es-ES" smtClean="0"/>
-              <a:t>12/09/2026</a:t>
+              <a:t>13/09/2026</a:t>
             </a:fld>
             <a:endParaRPr lang="es-ES"/>
           </a:p>
@@ -2383,7 +2383,7 @@
           <a:p>
             <a:fld id="{93065D2E-367D-4F9D-9E24-4F44260CE426}" type="datetimeFigureOut">
               <a:rPr lang="es-ES" smtClean="0"/>
-              <a:t>12/09/2026</a:t>
+              <a:t>13/09/2026</a:t>
             </a:fld>
             <a:endParaRPr lang="es-ES"/>
           </a:p>
@@ -2524,7 +2524,7 @@
           <a:p>
             <a:fld id="{93065D2E-367D-4F9D-9E24-4F44260CE426}" type="datetimeFigureOut">
               <a:rPr lang="es-ES" smtClean="0"/>
-              <a:t>12/09/2026</a:t>
+              <a:t>13/09/2026</a:t>
             </a:fld>
             <a:endParaRPr lang="es-ES"/>
           </a:p>
@@ -2637,7 +2637,7 @@
           <a:p>
             <a:fld id="{93065D2E-367D-4F9D-9E24-4F44260CE426}" type="datetimeFigureOut">
               <a:rPr lang="es-ES" smtClean="0"/>
-              <a:t>12/09/2026</a:t>
+              <a:t>13/09/2026</a:t>
             </a:fld>
             <a:endParaRPr lang="es-ES"/>
           </a:p>
@@ -2948,7 +2948,7 @@
           <a:p>
             <a:fld id="{93065D2E-367D-4F9D-9E24-4F44260CE426}" type="datetimeFigureOut">
               <a:rPr lang="es-ES" smtClean="0"/>
-              <a:t>12/09/2026</a:t>
+              <a:t>13/09/2026</a:t>
             </a:fld>
             <a:endParaRPr lang="es-ES"/>
           </a:p>
@@ -3236,7 +3236,7 @@
           <a:p>
             <a:fld id="{93065D2E-367D-4F9D-9E24-4F44260CE426}" type="datetimeFigureOut">
               <a:rPr lang="es-ES" smtClean="0"/>
-              <a:t>12/09/2026</a:t>
+              <a:t>13/09/2026</a:t>
             </a:fld>
             <a:endParaRPr lang="es-ES"/>
           </a:p>
@@ -3477,7 +3477,7 @@
           <a:p>
             <a:fld id="{93065D2E-367D-4F9D-9E24-4F44260CE426}" type="datetimeFigureOut">
               <a:rPr lang="es-ES" smtClean="0"/>
-              <a:t>12/09/2026</a:t>
+              <a:t>13/09/2026</a:t>
             </a:fld>
             <a:endParaRPr lang="es-ES"/>
           </a:p>
@@ -10936,6 +10936,66 @@
       </p:grpSpPr>
       <p:pic>
         <p:nvPicPr>
+          <p:cNvPr id="4" name="Imagen 3">
+            <a:extLst>
+              <a:ext uri="{FF2B5EF4-FFF2-40B4-BE49-F238E27FC236}">
+                <a16:creationId xmlns:a16="http://schemas.microsoft.com/office/drawing/2014/main" id="{AD8A2F39-A04F-8F57-6E10-6FD7ADE09F20}"/>
+              </a:ext>
+            </a:extLst>
+          </p:cNvPr>
+          <p:cNvPicPr>
+            <a:picLocks noChangeAspect="1"/>
+          </p:cNvPicPr>
+          <p:nvPr/>
+        </p:nvPicPr>
+        <p:blipFill>
+          <a:blip r:embed="rId2"/>
+          <a:stretch>
+            <a:fillRect/>
+          </a:stretch>
+        </p:blipFill>
+        <p:spPr>
+          <a:xfrm>
+            <a:off x="3347215" y="376547"/>
+            <a:ext cx="8192643" cy="3467584"/>
+          </a:xfrm>
+          <a:prstGeom prst="rect">
+            <a:avLst/>
+          </a:prstGeom>
+        </p:spPr>
+      </p:pic>
+      <p:pic>
+        <p:nvPicPr>
+          <p:cNvPr id="6" name="Imagen 5">
+            <a:extLst>
+              <a:ext uri="{FF2B5EF4-FFF2-40B4-BE49-F238E27FC236}">
+                <a16:creationId xmlns:a16="http://schemas.microsoft.com/office/drawing/2014/main" id="{758A630B-8337-EE3B-85B4-9B0B4475F8D2}"/>
+              </a:ext>
+            </a:extLst>
+          </p:cNvPr>
+          <p:cNvPicPr>
+            <a:picLocks noChangeAspect="1"/>
+          </p:cNvPicPr>
+          <p:nvPr/>
+        </p:nvPicPr>
+        <p:blipFill>
+          <a:blip r:embed="rId3"/>
+          <a:stretch>
+            <a:fillRect/>
+          </a:stretch>
+        </p:blipFill>
+        <p:spPr>
+          <a:xfrm>
+            <a:off x="1723198" y="4076138"/>
+            <a:ext cx="8240275" cy="2286319"/>
+          </a:xfrm>
+          <a:prstGeom prst="rect">
+            <a:avLst/>
+          </a:prstGeom>
+        </p:spPr>
+      </p:pic>
+      <p:pic>
+        <p:nvPicPr>
           <p:cNvPr id="3" name="Imagen 2">
             <a:extLst>
               <a:ext uri="{FF2B5EF4-FFF2-40B4-BE49-F238E27FC236}">
@@ -10949,7 +11009,7 @@
           <p:nvPr/>
         </p:nvPicPr>
         <p:blipFill>
-          <a:blip r:embed="rId2">
+          <a:blip r:embed="rId4">
             <a:clrChange>
               <a:clrFrom>
                 <a:srgbClr val="FFFFFF"/>
@@ -10972,12 +11032,30 @@
         </p:blipFill>
         <p:spPr>
           <a:xfrm flipH="1">
-            <a:off x="3055559" y="1437997"/>
+            <a:off x="8694520" y="4261566"/>
             <a:ext cx="987517" cy="957731"/>
           </a:xfrm>
           <a:prstGeom prst="rect">
             <a:avLst/>
           </a:prstGeom>
+          <a:solidFill>
+            <a:schemeClr val="bg1"/>
+          </a:solidFill>
+          <a:ln>
+            <a:solidFill>
+              <a:schemeClr val="tx1">
+                <a:lumMod val="50000"/>
+                <a:lumOff val="50000"/>
+              </a:schemeClr>
+            </a:solidFill>
+          </a:ln>
+          <a:effectLst>
+            <a:outerShdw blurRad="50800" dist="38100" dir="2700000" algn="tl" rotWithShape="0">
+              <a:prstClr val="black">
+                <a:alpha val="40000"/>
+              </a:prstClr>
+            </a:outerShdw>
+          </a:effectLst>
         </p:spPr>
       </p:pic>
     </p:spTree>

</xml_diff>

<commit_message>
New archetypes in basic profile.
</commit_message>
<xml_diff>
--- a/documentation/Refactorización XLST.pptx
+++ b/documentation/Refactorización XLST.pptx
@@ -9,6 +9,7 @@
     <p:sldId id="258" r:id="rId3"/>
     <p:sldId id="259" r:id="rId4"/>
     <p:sldId id="260" r:id="rId5"/>
+    <p:sldId id="261" r:id="rId6"/>
   </p:sldIdLst>
   <p:sldSz cx="12192000" cy="6858000"/>
   <p:notesSz cx="6797675" cy="9872663"/>
@@ -827,7 +828,7 @@
           <a:p>
             <a:fld id="{93065D2E-367D-4F9D-9E24-4F44260CE426}" type="datetimeFigureOut">
               <a:rPr lang="es-ES" smtClean="0"/>
-              <a:t>13/09/2026</a:t>
+              <a:t>14/09/2026</a:t>
             </a:fld>
             <a:endParaRPr lang="es-ES"/>
           </a:p>
@@ -1025,7 +1026,7 @@
           <a:p>
             <a:fld id="{93065D2E-367D-4F9D-9E24-4F44260CE426}" type="datetimeFigureOut">
               <a:rPr lang="es-ES" smtClean="0"/>
-              <a:t>13/09/2026</a:t>
+              <a:t>14/09/2026</a:t>
             </a:fld>
             <a:endParaRPr lang="es-ES"/>
           </a:p>
@@ -1233,7 +1234,7 @@
           <a:p>
             <a:fld id="{93065D2E-367D-4F9D-9E24-4F44260CE426}" type="datetimeFigureOut">
               <a:rPr lang="es-ES" smtClean="0"/>
-              <a:t>13/09/2026</a:t>
+              <a:t>14/09/2026</a:t>
             </a:fld>
             <a:endParaRPr lang="es-ES"/>
           </a:p>
@@ -1431,7 +1432,7 @@
           <a:p>
             <a:fld id="{93065D2E-367D-4F9D-9E24-4F44260CE426}" type="datetimeFigureOut">
               <a:rPr lang="es-ES" smtClean="0"/>
-              <a:t>13/09/2026</a:t>
+              <a:t>14/09/2026</a:t>
             </a:fld>
             <a:endParaRPr lang="es-ES"/>
           </a:p>
@@ -1706,7 +1707,7 @@
           <a:p>
             <a:fld id="{93065D2E-367D-4F9D-9E24-4F44260CE426}" type="datetimeFigureOut">
               <a:rPr lang="es-ES" smtClean="0"/>
-              <a:t>13/09/2026</a:t>
+              <a:t>14/09/2026</a:t>
             </a:fld>
             <a:endParaRPr lang="es-ES"/>
           </a:p>
@@ -1971,7 +1972,7 @@
           <a:p>
             <a:fld id="{93065D2E-367D-4F9D-9E24-4F44260CE426}" type="datetimeFigureOut">
               <a:rPr lang="es-ES" smtClean="0"/>
-              <a:t>13/09/2026</a:t>
+              <a:t>14/09/2026</a:t>
             </a:fld>
             <a:endParaRPr lang="es-ES"/>
           </a:p>
@@ -2383,7 +2384,7 @@
           <a:p>
             <a:fld id="{93065D2E-367D-4F9D-9E24-4F44260CE426}" type="datetimeFigureOut">
               <a:rPr lang="es-ES" smtClean="0"/>
-              <a:t>13/09/2026</a:t>
+              <a:t>14/09/2026</a:t>
             </a:fld>
             <a:endParaRPr lang="es-ES"/>
           </a:p>
@@ -2524,7 +2525,7 @@
           <a:p>
             <a:fld id="{93065D2E-367D-4F9D-9E24-4F44260CE426}" type="datetimeFigureOut">
               <a:rPr lang="es-ES" smtClean="0"/>
-              <a:t>13/09/2026</a:t>
+              <a:t>14/09/2026</a:t>
             </a:fld>
             <a:endParaRPr lang="es-ES"/>
           </a:p>
@@ -2637,7 +2638,7 @@
           <a:p>
             <a:fld id="{93065D2E-367D-4F9D-9E24-4F44260CE426}" type="datetimeFigureOut">
               <a:rPr lang="es-ES" smtClean="0"/>
-              <a:t>13/09/2026</a:t>
+              <a:t>14/09/2026</a:t>
             </a:fld>
             <a:endParaRPr lang="es-ES"/>
           </a:p>
@@ -2948,7 +2949,7 @@
           <a:p>
             <a:fld id="{93065D2E-367D-4F9D-9E24-4F44260CE426}" type="datetimeFigureOut">
               <a:rPr lang="es-ES" smtClean="0"/>
-              <a:t>13/09/2026</a:t>
+              <a:t>14/09/2026</a:t>
             </a:fld>
             <a:endParaRPr lang="es-ES"/>
           </a:p>
@@ -3236,7 +3237,7 @@
           <a:p>
             <a:fld id="{93065D2E-367D-4F9D-9E24-4F44260CE426}" type="datetimeFigureOut">
               <a:rPr lang="es-ES" smtClean="0"/>
-              <a:t>13/09/2026</a:t>
+              <a:t>14/09/2026</a:t>
             </a:fld>
             <a:endParaRPr lang="es-ES"/>
           </a:p>
@@ -3477,7 +3478,7 @@
           <a:p>
             <a:fld id="{93065D2E-367D-4F9D-9E24-4F44260CE426}" type="datetimeFigureOut">
               <a:rPr lang="es-ES" smtClean="0"/>
-              <a:t>13/09/2026</a:t>
+              <a:t>14/09/2026</a:t>
             </a:fld>
             <a:endParaRPr lang="es-ES"/>
           </a:p>
@@ -3908,10 +3909,10 @@
         </p:nvGrpSpPr>
         <p:grpSpPr>
           <a:xfrm>
-            <a:off x="2643298" y="276463"/>
-            <a:ext cx="3634969" cy="1426190"/>
-            <a:chOff x="873387" y="1307911"/>
-            <a:chExt cx="3634969" cy="1426190"/>
+            <a:off x="3403922" y="276463"/>
+            <a:ext cx="2113720" cy="1641634"/>
+            <a:chOff x="1634011" y="1307911"/>
+            <a:chExt cx="2113720" cy="1641634"/>
           </a:xfrm>
         </p:grpSpPr>
         <p:grpSp>
@@ -4147,8 +4148,8 @@
           </p:nvSpPr>
           <p:spPr>
             <a:xfrm>
-              <a:off x="873387" y="2210881"/>
-              <a:ext cx="3634969" cy="523220"/>
+              <a:off x="1634011" y="2210881"/>
+              <a:ext cx="2113720" cy="738664"/>
             </a:xfrm>
             <a:prstGeom prst="rect">
               <a:avLst/>
@@ -4175,7 +4176,16 @@
                 <a:rPr lang="es-ES" sz="1400" dirty="0">
                   <a:latin typeface="+mj-lt"/>
                 </a:rPr>
-                <a:t>(uno por idioma, sólo incluye a los dos archivos)</a:t>
+                <a:t>(uno por idioma, sólo</a:t>
+              </a:r>
+            </a:p>
+            <a:p>
+              <a:pPr algn="ctr"/>
+              <a:r>
+                <a:rPr lang="es-ES" sz="1400" dirty="0">
+                  <a:latin typeface="+mj-lt"/>
+                </a:rPr>
+                <a:t>incluye a los dos archivos)</a:t>
               </a:r>
             </a:p>
           </p:txBody>
@@ -4195,10 +4205,10 @@
         </p:nvGrpSpPr>
         <p:grpSpPr>
           <a:xfrm>
-            <a:off x="25473" y="941432"/>
-            <a:ext cx="3780651" cy="1641634"/>
-            <a:chOff x="800552" y="1307911"/>
-            <a:chExt cx="3780651" cy="1641634"/>
+            <a:off x="450654" y="941432"/>
+            <a:ext cx="2930289" cy="1857077"/>
+            <a:chOff x="1225733" y="1307911"/>
+            <a:chExt cx="2930289" cy="1857077"/>
           </a:xfrm>
         </p:grpSpPr>
         <p:grpSp>
@@ -4434,8 +4444,8 @@
           </p:nvSpPr>
           <p:spPr>
             <a:xfrm>
-              <a:off x="800552" y="2210881"/>
-              <a:ext cx="3780651" cy="738664"/>
+              <a:off x="1225733" y="2210881"/>
+              <a:ext cx="2930289" cy="954107"/>
             </a:xfrm>
             <a:prstGeom prst="rect">
               <a:avLst/>
@@ -4462,7 +4472,16 @@
                 <a:rPr lang="es-ES" sz="1400" dirty="0">
                   <a:latin typeface="+mj-lt"/>
                 </a:rPr>
-                <a:t>(uno por idioma, traduce todas las variables XSLT)</a:t>
+                <a:t>(uno por idioma, traduce </a:t>
+              </a:r>
+            </a:p>
+            <a:p>
+              <a:pPr algn="ctr"/>
+              <a:r>
+                <a:rPr lang="es-ES" sz="1400" dirty="0">
+                  <a:latin typeface="+mj-lt"/>
+                </a:rPr>
+                <a:t>todas las variables XSLT)</a:t>
               </a:r>
               <a:endParaRPr lang="es-ES" sz="1400" b="1" dirty="0">
                 <a:latin typeface="+mj-lt"/>
@@ -4773,9 +4792,9 @@
         <p:grpSpPr>
           <a:xfrm>
             <a:off x="2330323" y="3149273"/>
-            <a:ext cx="3341941" cy="2301269"/>
+            <a:ext cx="3341941" cy="2516713"/>
             <a:chOff x="4425036" y="3311364"/>
-            <a:chExt cx="3341941" cy="2301269"/>
+            <a:chExt cx="3341941" cy="2516713"/>
           </a:xfrm>
         </p:grpSpPr>
         <p:sp>
@@ -4895,9 +4914,9 @@
           <p:grpSpPr>
             <a:xfrm>
               <a:off x="4425036" y="3540112"/>
-              <a:ext cx="3341941" cy="2072521"/>
+              <a:ext cx="3341941" cy="2287965"/>
               <a:chOff x="1019916" y="1307911"/>
-              <a:chExt cx="3341941" cy="2072521"/>
+              <a:chExt cx="3341941" cy="2287965"/>
             </a:xfrm>
           </p:grpSpPr>
           <p:grpSp>
@@ -5134,7 +5153,7 @@
             <p:spPr>
               <a:xfrm>
                 <a:off x="1019916" y="2210881"/>
-                <a:ext cx="3341941" cy="1169551"/>
+                <a:ext cx="3341941" cy="1384995"/>
               </a:xfrm>
               <a:prstGeom prst="rect">
                 <a:avLst/>
@@ -5146,6 +5165,21 @@
                 <a:spAutoFit/>
               </a:bodyPr>
               <a:lstStyle/>
+              <a:p>
+                <a:pPr algn="ctr"/>
+                <a:r>
+                  <a:rPr lang="es-ES" sz="1400" dirty="0" err="1">
+                    <a:latin typeface="+mj-lt"/>
+                  </a:rPr>
+                  <a:t>labels</a:t>
+                </a:r>
+                <a:r>
+                  <a:rPr lang="es-ES" sz="1400" dirty="0">
+                    <a:latin typeface="+mj-lt"/>
+                  </a:rPr>
+                  <a:t>/class_labels.xsl</a:t>
+                </a:r>
+              </a:p>
               <a:p>
                 <a:pPr algn="ctr"/>
                 <a:r>
@@ -5231,8 +5265,8 @@
         </p:nvCxnSpPr>
         <p:spPr>
           <a:xfrm rot="10800000">
-            <a:off x="1915799" y="2583067"/>
-            <a:ext cx="1683170" cy="1232997"/>
+            <a:off x="1915799" y="2798509"/>
+            <a:ext cx="1683170" cy="1017554"/>
           </a:xfrm>
           <a:prstGeom prst="curvedConnector2">
             <a:avLst/>
@@ -5277,10 +5311,10 @@
         </p:nvGrpSpPr>
         <p:grpSpPr>
           <a:xfrm>
-            <a:off x="5977284" y="3136744"/>
-            <a:ext cx="1549975" cy="2085825"/>
-            <a:chOff x="5321017" y="3311364"/>
-            <a:chExt cx="1549975" cy="2085825"/>
+            <a:off x="5697086" y="3228184"/>
+            <a:ext cx="1872629" cy="2301269"/>
+            <a:chOff x="5159691" y="3311364"/>
+            <a:chExt cx="1872629" cy="2301269"/>
           </a:xfrm>
         </p:grpSpPr>
         <p:sp>
@@ -5399,10 +5433,10 @@
           </p:nvGrpSpPr>
           <p:grpSpPr>
             <a:xfrm>
-              <a:off x="5321017" y="3540112"/>
-              <a:ext cx="1549975" cy="1857077"/>
-              <a:chOff x="1915897" y="1307911"/>
-              <a:chExt cx="1549975" cy="1857077"/>
+              <a:off x="5159691" y="3540112"/>
+              <a:ext cx="1872629" cy="2072521"/>
+              <a:chOff x="1754571" y="1307911"/>
+              <a:chExt cx="1872629" cy="2072521"/>
             </a:xfrm>
           </p:grpSpPr>
           <p:grpSp>
@@ -5638,8 +5672,8 @@
             </p:nvSpPr>
             <p:spPr>
               <a:xfrm>
-                <a:off x="1915897" y="2210881"/>
-                <a:ext cx="1549975" cy="954107"/>
+                <a:off x="1754571" y="2210881"/>
+                <a:ext cx="1872629" cy="1169551"/>
               </a:xfrm>
               <a:prstGeom prst="rect">
                 <a:avLst/>
@@ -5709,6 +5743,21 @@
                     <a:latin typeface="+mj-lt"/>
                   </a:rPr>
                   <a:t>/cover.xsl</a:t>
+                </a:r>
+              </a:p>
+              <a:p>
+                <a:pPr algn="ctr"/>
+                <a:r>
+                  <a:rPr lang="es-ES" sz="1400" dirty="0" err="1">
+                    <a:latin typeface="+mj-lt"/>
+                  </a:rPr>
+                  <a:t>core</a:t>
+                </a:r>
+                <a:r>
+                  <a:rPr lang="es-ES" sz="1400" dirty="0">
+                    <a:latin typeface="+mj-lt"/>
+                  </a:rPr>
+                  <a:t>/generate_table.xsl</a:t>
                 </a:r>
               </a:p>
             </p:txBody>
@@ -5799,8 +5848,8 @@
           </p:nvSpPr>
           <p:spPr>
             <a:xfrm rot="20451329">
-              <a:off x="2684395" y="778370"/>
-              <a:ext cx="885179" cy="276999"/>
+              <a:off x="2610657" y="778370"/>
+              <a:ext cx="1032655" cy="276999"/>
             </a:xfrm>
             <a:prstGeom prst="rect">
               <a:avLst/>
@@ -5823,7 +5872,7 @@
               </a:r>
               <a:r>
                 <a:rPr lang="es-ES" sz="1200" dirty="0"/>
-                <a:t>»</a:t>
+                <a:t>» ①</a:t>
               </a:r>
             </a:p>
           </p:txBody>
@@ -5913,8 +5962,8 @@
           </p:nvSpPr>
           <p:spPr>
             <a:xfrm rot="1017362">
-              <a:off x="5334729" y="735499"/>
-              <a:ext cx="917239" cy="276999"/>
+              <a:off x="5277021" y="735499"/>
+              <a:ext cx="1032655" cy="276999"/>
             </a:xfrm>
             <a:prstGeom prst="rect">
               <a:avLst/>
@@ -5937,7 +5986,7 @@
               </a:r>
               <a:r>
                 <a:rPr lang="es-ES" sz="1200" dirty="0"/>
-                <a:t>»</a:t>
+                <a:t>» ②</a:t>
               </a:r>
             </a:p>
           </p:txBody>
@@ -6027,8 +6076,8 @@
           </p:nvSpPr>
           <p:spPr>
             <a:xfrm rot="19857530">
-              <a:off x="5406143" y="2613941"/>
-              <a:ext cx="917239" cy="276999"/>
+              <a:off x="5348435" y="2613941"/>
+              <a:ext cx="1032655" cy="276999"/>
             </a:xfrm>
             <a:prstGeom prst="rect">
               <a:avLst/>
@@ -6051,7 +6100,7 @@
               </a:r>
               <a:r>
                 <a:rPr lang="es-ES" sz="1200" dirty="0"/>
-                <a:t>»</a:t>
+                <a:t>» ①</a:t>
               </a:r>
             </a:p>
           </p:txBody>
@@ -6114,10 +6163,10 @@
         </p:nvGrpSpPr>
         <p:grpSpPr>
           <a:xfrm>
-            <a:off x="7630309" y="3141653"/>
-            <a:ext cx="3048527" cy="3593931"/>
-            <a:chOff x="4571744" y="3311364"/>
-            <a:chExt cx="3048527" cy="3593931"/>
+            <a:off x="7844427" y="2681538"/>
+            <a:ext cx="3426579" cy="4024818"/>
+            <a:chOff x="4382720" y="3311364"/>
+            <a:chExt cx="3426579" cy="4024818"/>
           </a:xfrm>
         </p:grpSpPr>
         <p:sp>
@@ -6236,10 +6285,10 @@
           </p:nvGrpSpPr>
           <p:grpSpPr>
             <a:xfrm>
-              <a:off x="4571744" y="3540112"/>
-              <a:ext cx="3048527" cy="3365183"/>
-              <a:chOff x="1166624" y="1307911"/>
-              <a:chExt cx="3048527" cy="3365183"/>
+              <a:off x="4382720" y="3540112"/>
+              <a:ext cx="3426579" cy="3796070"/>
+              <a:chOff x="977600" y="1307911"/>
+              <a:chExt cx="3426579" cy="3796070"/>
             </a:xfrm>
           </p:grpSpPr>
           <p:grpSp>
@@ -6475,8 +6524,8 @@
             </p:nvSpPr>
             <p:spPr>
               <a:xfrm>
-                <a:off x="1166624" y="2210881"/>
-                <a:ext cx="3048527" cy="2462213"/>
+                <a:off x="977600" y="2210881"/>
+                <a:ext cx="3426579" cy="2893100"/>
               </a:xfrm>
               <a:prstGeom prst="rect">
                 <a:avLst/>
@@ -6545,14 +6594,11 @@
                 </a:r>
                 <a:r>
                   <a:rPr lang="es-ES" sz="1400" dirty="0"/>
-                  <a:t>/general/</a:t>
-                </a:r>
-                <a:r>
-                  <a:rPr lang="es-ES" sz="1400" dirty="0">
-                    <a:latin typeface="+mj-lt"/>
-                  </a:rPr>
-                  <a:t>glossary_item.xsl</a:t>
-                </a:r>
+                  <a:t>/general/comment.xsl</a:t>
+                </a:r>
+                <a:endParaRPr lang="es-ES" sz="1400" dirty="0">
+                  <a:latin typeface="+mj-lt"/>
+                </a:endParaRPr>
               </a:p>
               <a:p>
                 <a:pPr algn="ctr"/>
@@ -6562,7 +6608,13 @@
                 </a:r>
                 <a:r>
                   <a:rPr lang="es-ES" sz="1400" dirty="0"/>
-                  <a:t>/general/figure.xsl</a:t>
+                  <a:t>/general/</a:t>
+                </a:r>
+                <a:r>
+                  <a:rPr lang="es-ES" sz="1400" dirty="0">
+                    <a:latin typeface="+mj-lt"/>
+                  </a:rPr>
+                  <a:t>glossary_item.xsl</a:t>
                 </a:r>
               </a:p>
               <a:p>
@@ -6573,7 +6625,7 @@
                 </a:r>
                 <a:r>
                   <a:rPr lang="es-ES" sz="1400" dirty="0"/>
-                  <a:t>/general/organization.xsl</a:t>
+                  <a:t>/general/bibliography_item.xsl</a:t>
                 </a:r>
               </a:p>
               <a:p>
@@ -6584,7 +6636,7 @@
                 </a:r>
                 <a:r>
                   <a:rPr lang="es-ES" sz="1400" dirty="0"/>
-                  <a:t>/general/stakeholder.xsl</a:t>
+                  <a:t>/general/figure.xsl</a:t>
                 </a:r>
               </a:p>
               <a:p>
@@ -6595,7 +6647,7 @@
                 </a:r>
                 <a:r>
                   <a:rPr lang="es-ES" sz="1400" dirty="0"/>
-                  <a:t>/general/symbolic_link.xsl</a:t>
+                  <a:t>/general/organization.xsl</a:t>
                 </a:r>
               </a:p>
               <a:p>
@@ -6606,25 +6658,51 @@
                 </a:r>
                 <a:r>
                   <a:rPr lang="es-ES" sz="1400" dirty="0"/>
-                  <a:t>/default.xsl</a:t>
+                  <a:t>/general/stakeholder.xsl</a:t>
                 </a:r>
               </a:p>
               <a:p>
                 <a:pPr algn="ctr"/>
                 <a:r>
-                  <a:rPr lang="es-ES" sz="1400" dirty="0">
-                    <a:latin typeface="+mj-lt"/>
-                  </a:rPr>
-                  <a:t>(HTML para arquetipos generales)</a:t>
+                  <a:rPr lang="es-ES" sz="1400" dirty="0" err="1"/>
+                  <a:t>archetypes</a:t>
+                </a:r>
+                <a:r>
+                  <a:rPr lang="es-ES" sz="1400" dirty="0"/>
+                  <a:t>/general/meeting.xsl</a:t>
                 </a:r>
               </a:p>
               <a:p>
                 <a:pPr algn="ctr"/>
                 <a:r>
-                  <a:rPr lang="es-ES" sz="1400" b="1" dirty="0">
-                    <a:latin typeface="+mj-lt"/>
-                  </a:rPr>
-                  <a:t>Falta la matriz de trazabilidad</a:t>
+                  <a:rPr lang="es-ES" sz="1400" dirty="0" err="1"/>
+                  <a:t>archetypes</a:t>
+                </a:r>
+                <a:r>
+                  <a:rPr lang="es-ES" sz="1400" dirty="0"/>
+                  <a:t>/general/traceability_matrix.xsl</a:t>
+                </a:r>
+              </a:p>
+              <a:p>
+                <a:pPr algn="ctr"/>
+                <a:r>
+                  <a:rPr lang="es-ES" sz="1400" dirty="0" err="1"/>
+                  <a:t>archetypes</a:t>
+                </a:r>
+                <a:r>
+                  <a:rPr lang="es-ES" sz="1400" dirty="0"/>
+                  <a:t>/general/symbolic_link.xsl</a:t>
+                </a:r>
+              </a:p>
+              <a:p>
+                <a:pPr algn="ctr"/>
+                <a:r>
+                  <a:rPr lang="es-ES" sz="1400" dirty="0" err="1"/>
+                  <a:t>archetypes</a:t>
+                </a:r>
+                <a:r>
+                  <a:rPr lang="es-ES" sz="1400" dirty="0"/>
+                  <a:t>/any_archetype.xsl</a:t>
                 </a:r>
               </a:p>
             </p:txBody>
@@ -6645,10 +6723,10 @@
         </p:nvGrpSpPr>
         <p:grpSpPr>
           <a:xfrm>
-            <a:off x="6872532" y="2152180"/>
-            <a:ext cx="344771" cy="984565"/>
-            <a:chOff x="3630531" y="3106613"/>
-            <a:chExt cx="366962" cy="859309"/>
+            <a:off x="6837828" y="2152180"/>
+            <a:ext cx="379448" cy="1076005"/>
+            <a:chOff x="3593621" y="3106617"/>
+            <a:chExt cx="403874" cy="939117"/>
           </a:xfrm>
         </p:grpSpPr>
         <p:cxnSp>
@@ -6669,8 +6747,8 @@
           </p:nvCxnSpPr>
           <p:spPr>
             <a:xfrm flipH="1">
-              <a:off x="3909236" y="3106613"/>
-              <a:ext cx="88257" cy="859309"/>
+              <a:off x="3782715" y="3106617"/>
+              <a:ext cx="214780" cy="939117"/>
             </a:xfrm>
             <a:prstGeom prst="straightConnector1">
               <a:avLst/>
@@ -6714,9 +6792,9 @@
             <p:nvPr/>
           </p:nvSpPr>
           <p:spPr>
-            <a:xfrm rot="16438953">
-              <a:off x="3423359" y="3382945"/>
-              <a:ext cx="752144" cy="337799"/>
+            <a:xfrm rot="16770414">
+              <a:off x="3290395" y="3444334"/>
+              <a:ext cx="901281" cy="294829"/>
             </a:xfrm>
             <a:prstGeom prst="rect">
               <a:avLst/>
@@ -6739,7 +6817,7 @@
               </a:r>
               <a:r>
                 <a:rPr lang="es-ES" sz="1200" dirty="0"/>
-                <a:t>»</a:t>
+                <a:t>» ②</a:t>
               </a:r>
             </a:p>
           </p:txBody>
@@ -6759,10 +6837,10 @@
         </p:nvGrpSpPr>
         <p:grpSpPr>
           <a:xfrm>
-            <a:off x="7217301" y="2152181"/>
-            <a:ext cx="2319378" cy="989475"/>
-            <a:chOff x="2303215" y="3192852"/>
-            <a:chExt cx="2468655" cy="863594"/>
+            <a:off x="7217301" y="2152179"/>
+            <a:ext cx="1938088" cy="1196149"/>
+            <a:chOff x="2303215" y="3192851"/>
+            <a:chExt cx="2062826" cy="1043975"/>
           </a:xfrm>
         </p:grpSpPr>
         <p:cxnSp>
@@ -6777,14 +6855,14 @@
             <p:cNvCxnSpPr>
               <a:cxnSpLocks/>
               <a:stCxn id="21" idx="2"/>
-              <a:endCxn id="75" idx="0"/>
+              <a:endCxn id="82" idx="1"/>
             </p:cNvCxnSpPr>
             <p:nvPr/>
           </p:nvCxnSpPr>
           <p:spPr>
             <a:xfrm>
-              <a:off x="2303215" y="3192852"/>
-              <a:ext cx="2468655" cy="863594"/>
+              <a:off x="2303215" y="3192851"/>
+              <a:ext cx="2062826" cy="1043975"/>
             </a:xfrm>
             <a:prstGeom prst="straightConnector1">
               <a:avLst/>
@@ -6828,9 +6906,9 @@
             <p:nvPr/>
           </p:nvSpPr>
           <p:spPr>
-            <a:xfrm rot="1403111">
-              <a:off x="3141104" y="3361681"/>
-              <a:ext cx="917244" cy="276997"/>
+            <a:xfrm rot="1875661">
+              <a:off x="2962574" y="3514971"/>
+              <a:ext cx="1099117" cy="241759"/>
             </a:xfrm>
             <a:prstGeom prst="rect">
               <a:avLst/>
@@ -6853,7 +6931,7 @@
               </a:r>
               <a:r>
                 <a:rPr lang="es-ES" sz="1200" dirty="0"/>
-                <a:t>»</a:t>
+                <a:t>» ③</a:t>
               </a:r>
             </a:p>
           </p:txBody>
@@ -11071,6 +11149,371 @@
 </p:sld>
 </file>
 
+<file path=ppt/slides/slide5.xml><?xml version="1.0" encoding="utf-8"?>
+<p:sld xmlns:a="http://schemas.openxmlformats.org/drawingml/2006/main" xmlns:r="http://schemas.openxmlformats.org/officeDocument/2006/relationships" xmlns:p="http://schemas.openxmlformats.org/presentationml/2006/main">
+  <p:cSld>
+    <p:spTree>
+      <p:nvGrpSpPr>
+        <p:cNvPr id="1" name=""/>
+        <p:cNvGrpSpPr/>
+        <p:nvPr/>
+      </p:nvGrpSpPr>
+      <p:grpSpPr>
+        <a:xfrm>
+          <a:off x="0" y="0"/>
+          <a:ext cx="0" cy="0"/>
+          <a:chOff x="0" y="0"/>
+          <a:chExt cx="0" cy="0"/>
+        </a:xfrm>
+      </p:grpSpPr>
+      <p:sp>
+        <p:nvSpPr>
+          <p:cNvPr id="13" name="Elipse 12">
+            <a:extLst>
+              <a:ext uri="{FF2B5EF4-FFF2-40B4-BE49-F238E27FC236}">
+                <a16:creationId xmlns:a16="http://schemas.microsoft.com/office/drawing/2014/main" id="{DD1F338A-52ED-F531-9B34-E3DBF79F475C}"/>
+              </a:ext>
+            </a:extLst>
+          </p:cNvPr>
+          <p:cNvSpPr/>
+          <p:nvPr/>
+        </p:nvSpPr>
+        <p:spPr>
+          <a:xfrm>
+            <a:off x="5752499" y="3076032"/>
+            <a:ext cx="687003" cy="687003"/>
+          </a:xfrm>
+          <a:prstGeom prst="ellipse">
+            <a:avLst/>
+          </a:prstGeom>
+          <a:solidFill>
+            <a:srgbClr val="FFC000"/>
+          </a:solidFill>
+          <a:ln>
+            <a:noFill/>
+          </a:ln>
+        </p:spPr>
+        <p:style>
+          <a:lnRef idx="2">
+            <a:schemeClr val="accent1">
+              <a:shade val="15000"/>
+            </a:schemeClr>
+          </a:lnRef>
+          <a:fillRef idx="1">
+            <a:schemeClr val="accent1"/>
+          </a:fillRef>
+          <a:effectRef idx="0">
+            <a:schemeClr val="accent1"/>
+          </a:effectRef>
+          <a:fontRef idx="minor">
+            <a:schemeClr val="lt1"/>
+          </a:fontRef>
+        </p:style>
+        <p:txBody>
+          <a:bodyPr rtlCol="0" anchor="ctr"/>
+          <a:lstStyle/>
+          <a:p>
+            <a:pPr algn="ctr"/>
+            <a:endParaRPr lang="es-ES"/>
+          </a:p>
+        </p:txBody>
+      </p:sp>
+      <p:pic>
+        <p:nvPicPr>
+          <p:cNvPr id="3" name="Imagen 2">
+            <a:extLst>
+              <a:ext uri="{FF2B5EF4-FFF2-40B4-BE49-F238E27FC236}">
+                <a16:creationId xmlns:a16="http://schemas.microsoft.com/office/drawing/2014/main" id="{A81D8D0D-F127-EDF4-179E-8739ADFA4EEC}"/>
+              </a:ext>
+            </a:extLst>
+          </p:cNvPr>
+          <p:cNvPicPr>
+            <a:picLocks noChangeAspect="1"/>
+          </p:cNvPicPr>
+          <p:nvPr/>
+        </p:nvPicPr>
+        <p:blipFill>
+          <a:blip r:embed="rId2">
+            <a:extLst>
+              <a:ext uri="{28A0092B-C50C-407E-A947-70E740481C1C}">
+                <a14:useLocalDpi xmlns:a14="http://schemas.microsoft.com/office/drawing/2010/main" val="0"/>
+              </a:ext>
+            </a:extLst>
+          </a:blip>
+          <a:stretch>
+            <a:fillRect/>
+          </a:stretch>
+        </p:blipFill>
+        <p:spPr>
+          <a:xfrm>
+            <a:off x="5782002" y="3114771"/>
+            <a:ext cx="609524" cy="609524"/>
+          </a:xfrm>
+          <a:prstGeom prst="rect">
+            <a:avLst/>
+          </a:prstGeom>
+        </p:spPr>
+      </p:pic>
+      <p:pic>
+        <p:nvPicPr>
+          <p:cNvPr id="5" name="Imagen 4">
+            <a:extLst>
+              <a:ext uri="{FF2B5EF4-FFF2-40B4-BE49-F238E27FC236}">
+                <a16:creationId xmlns:a16="http://schemas.microsoft.com/office/drawing/2014/main" id="{B50BD451-E336-0E66-D3DC-99E9E69AE20B}"/>
+              </a:ext>
+            </a:extLst>
+          </p:cNvPr>
+          <p:cNvPicPr>
+            <a:picLocks noChangeAspect="1"/>
+          </p:cNvPicPr>
+          <p:nvPr/>
+        </p:nvPicPr>
+        <p:blipFill>
+          <a:blip r:embed="rId3">
+            <a:extLst>
+              <a:ext uri="{28A0092B-C50C-407E-A947-70E740481C1C}">
+                <a14:useLocalDpi xmlns:a14="http://schemas.microsoft.com/office/drawing/2010/main" val="0"/>
+              </a:ext>
+            </a:extLst>
+          </a:blip>
+          <a:stretch>
+            <a:fillRect/>
+          </a:stretch>
+        </p:blipFill>
+        <p:spPr>
+          <a:xfrm>
+            <a:off x="4623816" y="2286000"/>
+            <a:ext cx="457200" cy="457200"/>
+          </a:xfrm>
+          <a:prstGeom prst="rect">
+            <a:avLst/>
+          </a:prstGeom>
+        </p:spPr>
+      </p:pic>
+      <p:pic>
+        <p:nvPicPr>
+          <p:cNvPr id="7" name="Imagen 6">
+            <a:extLst>
+              <a:ext uri="{FF2B5EF4-FFF2-40B4-BE49-F238E27FC236}">
+                <a16:creationId xmlns:a16="http://schemas.microsoft.com/office/drawing/2014/main" id="{9FC83CCA-2666-E39A-15D7-F74178653A69}"/>
+              </a:ext>
+            </a:extLst>
+          </p:cNvPr>
+          <p:cNvPicPr>
+            <a:picLocks noChangeAspect="1"/>
+          </p:cNvPicPr>
+          <p:nvPr/>
+        </p:nvPicPr>
+        <p:blipFill>
+          <a:blip r:embed="rId4">
+            <a:extLst>
+              <a:ext uri="{28A0092B-C50C-407E-A947-70E740481C1C}">
+                <a14:useLocalDpi xmlns:a14="http://schemas.microsoft.com/office/drawing/2010/main" val="0"/>
+              </a:ext>
+            </a:extLst>
+          </a:blip>
+          <a:stretch>
+            <a:fillRect/>
+          </a:stretch>
+        </p:blipFill>
+        <p:spPr>
+          <a:xfrm>
+            <a:off x="9098356" y="954100"/>
+            <a:ext cx="608400" cy="608400"/>
+          </a:xfrm>
+          <a:prstGeom prst="rect">
+            <a:avLst/>
+          </a:prstGeom>
+        </p:spPr>
+      </p:pic>
+      <p:pic>
+        <p:nvPicPr>
+          <p:cNvPr id="9" name="Imagen 8">
+            <a:extLst>
+              <a:ext uri="{FF2B5EF4-FFF2-40B4-BE49-F238E27FC236}">
+                <a16:creationId xmlns:a16="http://schemas.microsoft.com/office/drawing/2014/main" id="{E03FBA85-7AFD-EF2D-779B-AF7823EF5D61}"/>
+              </a:ext>
+            </a:extLst>
+          </p:cNvPr>
+          <p:cNvPicPr>
+            <a:picLocks noChangeAspect="1"/>
+          </p:cNvPicPr>
+          <p:nvPr/>
+        </p:nvPicPr>
+        <p:blipFill>
+          <a:blip r:embed="rId5">
+            <a:extLst>
+              <a:ext uri="{28A0092B-C50C-407E-A947-70E740481C1C}">
+                <a14:useLocalDpi xmlns:a14="http://schemas.microsoft.com/office/drawing/2010/main" val="0"/>
+              </a:ext>
+            </a:extLst>
+          </a:blip>
+          <a:stretch>
+            <a:fillRect/>
+          </a:stretch>
+        </p:blipFill>
+        <p:spPr>
+          <a:xfrm>
+            <a:off x="9183662" y="2054390"/>
+            <a:ext cx="609524" cy="609524"/>
+          </a:xfrm>
+          <a:prstGeom prst="rect">
+            <a:avLst/>
+          </a:prstGeom>
+        </p:spPr>
+      </p:pic>
+      <p:pic>
+        <p:nvPicPr>
+          <p:cNvPr id="12" name="Imagen 11" descr="Imágenes de Lexicon Icon: descubre bancos de fotos, ilustraciones, vectores  y vídeos de 31,485 | Adobe Stock">
+            <a:extLst>
+              <a:ext uri="{FF2B5EF4-FFF2-40B4-BE49-F238E27FC236}">
+                <a16:creationId xmlns:a16="http://schemas.microsoft.com/office/drawing/2014/main" id="{829BEA07-C01A-615F-F916-F89E2D2E612E}"/>
+              </a:ext>
+            </a:extLst>
+          </p:cNvPr>
+          <p:cNvPicPr>
+            <a:picLocks noChangeAspect="1"/>
+          </p:cNvPicPr>
+          <p:nvPr/>
+        </p:nvPicPr>
+        <p:blipFill>
+          <a:blip r:embed="rId6"/>
+          <a:srcRect l="59482" t="24182" r="13550" b="24671"/>
+          <a:stretch>
+            <a:fillRect/>
+          </a:stretch>
+        </p:blipFill>
+        <p:spPr>
+          <a:xfrm>
+            <a:off x="2235993" y="2002629"/>
+            <a:ext cx="608400" cy="644028"/>
+          </a:xfrm>
+          <a:prstGeom prst="rect">
+            <a:avLst/>
+          </a:prstGeom>
+        </p:spPr>
+      </p:pic>
+      <p:pic>
+        <p:nvPicPr>
+          <p:cNvPr id="15" name="Imagen 14">
+            <a:extLst>
+              <a:ext uri="{FF2B5EF4-FFF2-40B4-BE49-F238E27FC236}">
+                <a16:creationId xmlns:a16="http://schemas.microsoft.com/office/drawing/2014/main" id="{ABE1D1ED-6BC6-5390-D923-5093CAA8836A}"/>
+              </a:ext>
+            </a:extLst>
+          </p:cNvPr>
+          <p:cNvPicPr>
+            <a:picLocks noChangeAspect="1"/>
+          </p:cNvPicPr>
+          <p:nvPr/>
+        </p:nvPicPr>
+        <p:blipFill>
+          <a:blip r:embed="rId7">
+            <a:extLst>
+              <a:ext uri="{28A0092B-C50C-407E-A947-70E740481C1C}">
+                <a14:useLocalDpi xmlns:a14="http://schemas.microsoft.com/office/drawing/2010/main" val="0"/>
+              </a:ext>
+            </a:extLst>
+          </a:blip>
+          <a:stretch>
+            <a:fillRect/>
+          </a:stretch>
+        </p:blipFill>
+        <p:spPr>
+          <a:xfrm>
+            <a:off x="8510561" y="3521363"/>
+            <a:ext cx="608400" cy="608400"/>
+          </a:xfrm>
+          <a:prstGeom prst="rect">
+            <a:avLst/>
+          </a:prstGeom>
+        </p:spPr>
+      </p:pic>
+      <p:pic>
+        <p:nvPicPr>
+          <p:cNvPr id="17" name="Imagen 16">
+            <a:extLst>
+              <a:ext uri="{FF2B5EF4-FFF2-40B4-BE49-F238E27FC236}">
+                <a16:creationId xmlns:a16="http://schemas.microsoft.com/office/drawing/2014/main" id="{E96634AB-D6CD-A32F-102E-CC0651C9908D}"/>
+              </a:ext>
+            </a:extLst>
+          </p:cNvPr>
+          <p:cNvPicPr>
+            <a:picLocks noChangeAspect="1"/>
+          </p:cNvPicPr>
+          <p:nvPr/>
+        </p:nvPicPr>
+        <p:blipFill>
+          <a:blip r:embed="rId2">
+            <a:extLst>
+              <a:ext uri="{28A0092B-C50C-407E-A947-70E740481C1C}">
+                <a14:useLocalDpi xmlns:a14="http://schemas.microsoft.com/office/drawing/2010/main" val="0"/>
+              </a:ext>
+            </a:extLst>
+          </a:blip>
+          <a:stretch>
+            <a:fillRect/>
+          </a:stretch>
+        </p:blipFill>
+        <p:spPr>
+          <a:xfrm>
+            <a:off x="7712401" y="3520239"/>
+            <a:ext cx="609524" cy="609524"/>
+          </a:xfrm>
+          <a:prstGeom prst="rect">
+            <a:avLst/>
+          </a:prstGeom>
+        </p:spPr>
+      </p:pic>
+      <p:pic>
+        <p:nvPicPr>
+          <p:cNvPr id="11" name="Imagen 10">
+            <a:extLst>
+              <a:ext uri="{FF2B5EF4-FFF2-40B4-BE49-F238E27FC236}">
+                <a16:creationId xmlns:a16="http://schemas.microsoft.com/office/drawing/2014/main" id="{D1DC5D30-9F2E-487B-2F6F-60DE3579B341}"/>
+              </a:ext>
+            </a:extLst>
+          </p:cNvPr>
+          <p:cNvPicPr>
+            <a:picLocks noChangeAspect="1"/>
+          </p:cNvPicPr>
+          <p:nvPr/>
+        </p:nvPicPr>
+        <p:blipFill>
+          <a:blip r:embed="rId8">
+            <a:extLst>
+              <a:ext uri="{28A0092B-C50C-407E-A947-70E740481C1C}">
+                <a14:useLocalDpi xmlns:a14="http://schemas.microsoft.com/office/drawing/2010/main" val="0"/>
+              </a:ext>
+            </a:extLst>
+          </a:blip>
+          <a:stretch>
+            <a:fillRect/>
+          </a:stretch>
+        </p:blipFill>
+        <p:spPr>
+          <a:xfrm>
+            <a:off x="2407703" y="2074305"/>
+            <a:ext cx="378868" cy="378868"/>
+          </a:xfrm>
+          <a:prstGeom prst="rect">
+            <a:avLst/>
+          </a:prstGeom>
+        </p:spPr>
+      </p:pic>
+    </p:spTree>
+    <p:extLst>
+      <p:ext uri="{BB962C8B-B14F-4D97-AF65-F5344CB8AC3E}">
+        <p14:creationId xmlns:p14="http://schemas.microsoft.com/office/powerpoint/2010/main" val="1027079573"/>
+      </p:ext>
+    </p:extLst>
+  </p:cSld>
+  <p:clrMapOvr>
+    <a:masterClrMapping/>
+  </p:clrMapOvr>
+</p:sld>
+</file>
+
 <file path=ppt/theme/theme1.xml><?xml version="1.0" encoding="utf-8"?>
 <a:theme xmlns:a="http://schemas.openxmlformats.org/drawingml/2006/main" name="Tema de Office">
   <a:themeElements>

</xml_diff>

<commit_message>
Mejorando el XSLT del arquetipo básico.
</commit_message>
<xml_diff>
--- a/documentation/Refactorización XLST.pptx
+++ b/documentation/Refactorización XLST.pptx
@@ -8,11 +8,12 @@
     <p:sldId id="257" r:id="rId2"/>
     <p:sldId id="258" r:id="rId3"/>
     <p:sldId id="259" r:id="rId4"/>
-    <p:sldId id="260" r:id="rId5"/>
-    <p:sldId id="261" r:id="rId6"/>
+    <p:sldId id="262" r:id="rId5"/>
+    <p:sldId id="260" r:id="rId6"/>
+    <p:sldId id="261" r:id="rId7"/>
   </p:sldIdLst>
   <p:sldSz cx="12192000" cy="6858000"/>
-  <p:notesSz cx="6797675" cy="9872663"/>
+  <p:notesSz cx="6797675" cy="9926638"/>
   <p:defaultTextStyle>
     <a:defPPr>
       <a:defRPr lang="es-ES"/>
@@ -828,7 +829,7 @@
           <a:p>
             <a:fld id="{93065D2E-367D-4F9D-9E24-4F44260CE426}" type="datetimeFigureOut">
               <a:rPr lang="es-ES" smtClean="0"/>
-              <a:t>14/09/2026</a:t>
+              <a:t>17/09/2026</a:t>
             </a:fld>
             <a:endParaRPr lang="es-ES"/>
           </a:p>
@@ -1026,7 +1027,7 @@
           <a:p>
             <a:fld id="{93065D2E-367D-4F9D-9E24-4F44260CE426}" type="datetimeFigureOut">
               <a:rPr lang="es-ES" smtClean="0"/>
-              <a:t>14/09/2026</a:t>
+              <a:t>17/09/2026</a:t>
             </a:fld>
             <a:endParaRPr lang="es-ES"/>
           </a:p>
@@ -1234,7 +1235,7 @@
           <a:p>
             <a:fld id="{93065D2E-367D-4F9D-9E24-4F44260CE426}" type="datetimeFigureOut">
               <a:rPr lang="es-ES" smtClean="0"/>
-              <a:t>14/09/2026</a:t>
+              <a:t>17/09/2026</a:t>
             </a:fld>
             <a:endParaRPr lang="es-ES"/>
           </a:p>
@@ -1432,7 +1433,7 @@
           <a:p>
             <a:fld id="{93065D2E-367D-4F9D-9E24-4F44260CE426}" type="datetimeFigureOut">
               <a:rPr lang="es-ES" smtClean="0"/>
-              <a:t>14/09/2026</a:t>
+              <a:t>17/09/2026</a:t>
             </a:fld>
             <a:endParaRPr lang="es-ES"/>
           </a:p>
@@ -1707,7 +1708,7 @@
           <a:p>
             <a:fld id="{93065D2E-367D-4F9D-9E24-4F44260CE426}" type="datetimeFigureOut">
               <a:rPr lang="es-ES" smtClean="0"/>
-              <a:t>14/09/2026</a:t>
+              <a:t>17/09/2026</a:t>
             </a:fld>
             <a:endParaRPr lang="es-ES"/>
           </a:p>
@@ -1972,7 +1973,7 @@
           <a:p>
             <a:fld id="{93065D2E-367D-4F9D-9E24-4F44260CE426}" type="datetimeFigureOut">
               <a:rPr lang="es-ES" smtClean="0"/>
-              <a:t>14/09/2026</a:t>
+              <a:t>17/09/2026</a:t>
             </a:fld>
             <a:endParaRPr lang="es-ES"/>
           </a:p>
@@ -2384,7 +2385,7 @@
           <a:p>
             <a:fld id="{93065D2E-367D-4F9D-9E24-4F44260CE426}" type="datetimeFigureOut">
               <a:rPr lang="es-ES" smtClean="0"/>
-              <a:t>14/09/2026</a:t>
+              <a:t>17/09/2026</a:t>
             </a:fld>
             <a:endParaRPr lang="es-ES"/>
           </a:p>
@@ -2525,7 +2526,7 @@
           <a:p>
             <a:fld id="{93065D2E-367D-4F9D-9E24-4F44260CE426}" type="datetimeFigureOut">
               <a:rPr lang="es-ES" smtClean="0"/>
-              <a:t>14/09/2026</a:t>
+              <a:t>17/09/2026</a:t>
             </a:fld>
             <a:endParaRPr lang="es-ES"/>
           </a:p>
@@ -2638,7 +2639,7 @@
           <a:p>
             <a:fld id="{93065D2E-367D-4F9D-9E24-4F44260CE426}" type="datetimeFigureOut">
               <a:rPr lang="es-ES" smtClean="0"/>
-              <a:t>14/09/2026</a:t>
+              <a:t>17/09/2026</a:t>
             </a:fld>
             <a:endParaRPr lang="es-ES"/>
           </a:p>
@@ -2949,7 +2950,7 @@
           <a:p>
             <a:fld id="{93065D2E-367D-4F9D-9E24-4F44260CE426}" type="datetimeFigureOut">
               <a:rPr lang="es-ES" smtClean="0"/>
-              <a:t>14/09/2026</a:t>
+              <a:t>17/09/2026</a:t>
             </a:fld>
             <a:endParaRPr lang="es-ES"/>
           </a:p>
@@ -3237,7 +3238,7 @@
           <a:p>
             <a:fld id="{93065D2E-367D-4F9D-9E24-4F44260CE426}" type="datetimeFigureOut">
               <a:rPr lang="es-ES" smtClean="0"/>
-              <a:t>14/09/2026</a:t>
+              <a:t>17/09/2026</a:t>
             </a:fld>
             <a:endParaRPr lang="es-ES"/>
           </a:p>
@@ -3478,7 +3479,7 @@
           <a:p>
             <a:fld id="{93065D2E-367D-4F9D-9E24-4F44260CE426}" type="datetimeFigureOut">
               <a:rPr lang="es-ES" smtClean="0"/>
-              <a:t>14/09/2026</a:t>
+              <a:t>17/09/2026</a:t>
             </a:fld>
             <a:endParaRPr lang="es-ES"/>
           </a:p>
@@ -11000,6 +11001,2198 @@
   <p:cSld>
     <p:spTree>
       <p:nvGrpSpPr>
+        <p:cNvPr id="1" name="">
+          <a:extLst>
+            <a:ext uri="{FF2B5EF4-FFF2-40B4-BE49-F238E27FC236}">
+              <a16:creationId xmlns:a16="http://schemas.microsoft.com/office/drawing/2014/main" id="{D5C71C02-4C4F-BEAD-244C-9E5149737A81}"/>
+            </a:ext>
+          </a:extLst>
+        </p:cNvPr>
+        <p:cNvGrpSpPr/>
+        <p:nvPr/>
+      </p:nvGrpSpPr>
+      <p:grpSpPr>
+        <a:xfrm>
+          <a:off x="0" y="0"/>
+          <a:ext cx="0" cy="0"/>
+          <a:chOff x="0" y="0"/>
+          <a:chExt cx="0" cy="0"/>
+        </a:xfrm>
+      </p:grpSpPr>
+      <p:grpSp>
+        <p:nvGrpSpPr>
+          <p:cNvPr id="19" name="Grupo 18">
+            <a:extLst>
+              <a:ext uri="{FF2B5EF4-FFF2-40B4-BE49-F238E27FC236}">
+                <a16:creationId xmlns:a16="http://schemas.microsoft.com/office/drawing/2014/main" id="{59E0911B-D3CB-8E42-B804-F5E9D91056BC}"/>
+              </a:ext>
+            </a:extLst>
+          </p:cNvPr>
+          <p:cNvGrpSpPr/>
+          <p:nvPr/>
+        </p:nvGrpSpPr>
+        <p:grpSpPr>
+          <a:xfrm>
+            <a:off x="7923769" y="683475"/>
+            <a:ext cx="1953996" cy="1426190"/>
+            <a:chOff x="1713879" y="1307911"/>
+            <a:chExt cx="1953996" cy="1426190"/>
+          </a:xfrm>
+        </p:grpSpPr>
+        <p:grpSp>
+          <p:nvGrpSpPr>
+            <p:cNvPr id="20" name="Grupo 19">
+              <a:extLst>
+                <a:ext uri="{FF2B5EF4-FFF2-40B4-BE49-F238E27FC236}">
+                  <a16:creationId xmlns:a16="http://schemas.microsoft.com/office/drawing/2014/main" id="{C6CBC92C-6EEF-1FCE-6980-BAFF71421728}"/>
+                </a:ext>
+              </a:extLst>
+            </p:cNvPr>
+            <p:cNvGrpSpPr/>
+            <p:nvPr/>
+          </p:nvGrpSpPr>
+          <p:grpSpPr>
+            <a:xfrm>
+              <a:off x="2288562" y="1307911"/>
+              <a:ext cx="804605" cy="882387"/>
+              <a:chOff x="2100116" y="1161875"/>
+              <a:chExt cx="1070929" cy="1174458"/>
+            </a:xfrm>
+          </p:grpSpPr>
+          <p:sp>
+            <p:nvSpPr>
+              <p:cNvPr id="22" name="Rectángulo 21">
+                <a:extLst>
+                  <a:ext uri="{FF2B5EF4-FFF2-40B4-BE49-F238E27FC236}">
+                    <a16:creationId xmlns:a16="http://schemas.microsoft.com/office/drawing/2014/main" id="{FC11EBC6-4A24-3782-99C5-079779AAC4DE}"/>
+                  </a:ext>
+                </a:extLst>
+              </p:cNvPr>
+              <p:cNvSpPr/>
+              <p:nvPr/>
+            </p:nvSpPr>
+            <p:spPr>
+              <a:xfrm>
+                <a:off x="2336341" y="1161875"/>
+                <a:ext cx="834704" cy="1174458"/>
+              </a:xfrm>
+              <a:prstGeom prst="rect">
+                <a:avLst/>
+              </a:prstGeom>
+              <a:solidFill>
+                <a:schemeClr val="bg2">
+                  <a:lumMod val="90000"/>
+                </a:schemeClr>
+              </a:solidFill>
+            </p:spPr>
+            <p:style>
+              <a:lnRef idx="2">
+                <a:schemeClr val="accent1">
+                  <a:shade val="15000"/>
+                </a:schemeClr>
+              </a:lnRef>
+              <a:fillRef idx="1">
+                <a:schemeClr val="accent1"/>
+              </a:fillRef>
+              <a:effectRef idx="0">
+                <a:schemeClr val="accent1"/>
+              </a:effectRef>
+              <a:fontRef idx="minor">
+                <a:schemeClr val="lt1"/>
+              </a:fontRef>
+            </p:style>
+            <p:txBody>
+              <a:bodyPr rtlCol="0" anchor="ctr"/>
+              <a:lstStyle/>
+              <a:p>
+                <a:pPr algn="ctr"/>
+                <a:endParaRPr lang="es-ES"/>
+              </a:p>
+            </p:txBody>
+          </p:sp>
+          <p:sp>
+            <p:nvSpPr>
+              <p:cNvPr id="23" name="Elipse 22">
+                <a:extLst>
+                  <a:ext uri="{FF2B5EF4-FFF2-40B4-BE49-F238E27FC236}">
+                    <a16:creationId xmlns:a16="http://schemas.microsoft.com/office/drawing/2014/main" id="{9FAEAC6B-160B-B272-1746-91D156DEAFFD}"/>
+                  </a:ext>
+                </a:extLst>
+              </p:cNvPr>
+              <p:cNvSpPr/>
+              <p:nvPr/>
+            </p:nvSpPr>
+            <p:spPr>
+              <a:xfrm>
+                <a:off x="2100116" y="1305718"/>
+                <a:ext cx="644427" cy="211459"/>
+              </a:xfrm>
+              <a:prstGeom prst="ellipse">
+                <a:avLst/>
+              </a:prstGeom>
+              <a:solidFill>
+                <a:schemeClr val="bg1"/>
+              </a:solidFill>
+            </p:spPr>
+            <p:style>
+              <a:lnRef idx="2">
+                <a:schemeClr val="accent1">
+                  <a:shade val="15000"/>
+                </a:schemeClr>
+              </a:lnRef>
+              <a:fillRef idx="1">
+                <a:schemeClr val="accent1"/>
+              </a:fillRef>
+              <a:effectRef idx="0">
+                <a:schemeClr val="accent1"/>
+              </a:effectRef>
+              <a:fontRef idx="minor">
+                <a:schemeClr val="lt1"/>
+              </a:fontRef>
+            </p:style>
+            <p:txBody>
+              <a:bodyPr rtlCol="0" anchor="ctr"/>
+              <a:lstStyle/>
+              <a:p>
+                <a:pPr algn="ctr"/>
+                <a:endParaRPr lang="es-ES"/>
+              </a:p>
+            </p:txBody>
+          </p:sp>
+          <p:sp>
+            <p:nvSpPr>
+              <p:cNvPr id="24" name="Rectángulo 23">
+                <a:extLst>
+                  <a:ext uri="{FF2B5EF4-FFF2-40B4-BE49-F238E27FC236}">
+                    <a16:creationId xmlns:a16="http://schemas.microsoft.com/office/drawing/2014/main" id="{9DC4398F-FF44-E465-48E6-2E5764AC725C}"/>
+                  </a:ext>
+                </a:extLst>
+              </p:cNvPr>
+              <p:cNvSpPr/>
+              <p:nvPr/>
+            </p:nvSpPr>
+            <p:spPr>
+              <a:xfrm>
+                <a:off x="2100116" y="1639180"/>
+                <a:ext cx="644427" cy="211459"/>
+              </a:xfrm>
+              <a:prstGeom prst="rect">
+                <a:avLst/>
+              </a:prstGeom>
+              <a:solidFill>
+                <a:schemeClr val="bg1"/>
+              </a:solidFill>
+            </p:spPr>
+            <p:style>
+              <a:lnRef idx="2">
+                <a:schemeClr val="accent1">
+                  <a:shade val="15000"/>
+                </a:schemeClr>
+              </a:lnRef>
+              <a:fillRef idx="1">
+                <a:schemeClr val="accent1"/>
+              </a:fillRef>
+              <a:effectRef idx="0">
+                <a:schemeClr val="accent1"/>
+              </a:effectRef>
+              <a:fontRef idx="minor">
+                <a:schemeClr val="lt1"/>
+              </a:fontRef>
+            </p:style>
+            <p:txBody>
+              <a:bodyPr rtlCol="0" anchor="ctr"/>
+              <a:lstStyle/>
+              <a:p>
+                <a:pPr algn="ctr"/>
+                <a:endParaRPr lang="es-ES"/>
+              </a:p>
+            </p:txBody>
+          </p:sp>
+          <p:sp>
+            <p:nvSpPr>
+              <p:cNvPr id="25" name="Rectángulo 24">
+                <a:extLst>
+                  <a:ext uri="{FF2B5EF4-FFF2-40B4-BE49-F238E27FC236}">
+                    <a16:creationId xmlns:a16="http://schemas.microsoft.com/office/drawing/2014/main" id="{9D04F2CF-3A14-7222-84AE-F7FEEA6E04F6}"/>
+                  </a:ext>
+                </a:extLst>
+              </p:cNvPr>
+              <p:cNvSpPr/>
+              <p:nvPr/>
+            </p:nvSpPr>
+            <p:spPr>
+              <a:xfrm>
+                <a:off x="2100116" y="1972642"/>
+                <a:ext cx="644427" cy="211459"/>
+              </a:xfrm>
+              <a:prstGeom prst="rect">
+                <a:avLst/>
+              </a:prstGeom>
+              <a:solidFill>
+                <a:schemeClr val="bg1"/>
+              </a:solidFill>
+            </p:spPr>
+            <p:style>
+              <a:lnRef idx="2">
+                <a:schemeClr val="accent1">
+                  <a:shade val="15000"/>
+                </a:schemeClr>
+              </a:lnRef>
+              <a:fillRef idx="1">
+                <a:schemeClr val="accent1"/>
+              </a:fillRef>
+              <a:effectRef idx="0">
+                <a:schemeClr val="accent1"/>
+              </a:effectRef>
+              <a:fontRef idx="minor">
+                <a:schemeClr val="lt1"/>
+              </a:fontRef>
+            </p:style>
+            <p:txBody>
+              <a:bodyPr rtlCol="0" anchor="ctr"/>
+              <a:lstStyle/>
+              <a:p>
+                <a:pPr algn="ctr"/>
+                <a:endParaRPr lang="es-ES"/>
+              </a:p>
+            </p:txBody>
+          </p:sp>
+        </p:grpSp>
+        <p:sp>
+          <p:nvSpPr>
+            <p:cNvPr id="21" name="CuadroTexto 20">
+              <a:extLst>
+                <a:ext uri="{FF2B5EF4-FFF2-40B4-BE49-F238E27FC236}">
+                  <a16:creationId xmlns:a16="http://schemas.microsoft.com/office/drawing/2014/main" id="{FDEB384F-F068-ACA5-2B9E-F6703B5214C7}"/>
+                </a:ext>
+              </a:extLst>
+            </p:cNvPr>
+            <p:cNvSpPr txBox="1"/>
+            <p:nvPr/>
+          </p:nvSpPr>
+          <p:spPr>
+            <a:xfrm>
+              <a:off x="1713879" y="2210881"/>
+              <a:ext cx="1953996" cy="523220"/>
+            </a:xfrm>
+            <a:prstGeom prst="rect">
+              <a:avLst/>
+            </a:prstGeom>
+            <a:noFill/>
+          </p:spPr>
+          <p:txBody>
+            <a:bodyPr wrap="none" rtlCol="0">
+              <a:spAutoFit/>
+            </a:bodyPr>
+            <a:lstStyle/>
+            <a:p>
+              <a:pPr algn="ctr"/>
+              <a:r>
+                <a:rPr lang="es-ES" sz="1400" dirty="0">
+                  <a:latin typeface="+mj-lt"/>
+                </a:rPr>
+                <a:t>default.xsl</a:t>
+              </a:r>
+            </a:p>
+            <a:p>
+              <a:pPr algn="ctr"/>
+              <a:r>
+                <a:rPr lang="es-ES" sz="1400" dirty="0">
+                  <a:latin typeface="+mj-lt"/>
+                </a:rPr>
+                <a:t>(punto de entrada único)</a:t>
+              </a:r>
+            </a:p>
+          </p:txBody>
+        </p:sp>
+      </p:grpSp>
+      <p:cxnSp>
+        <p:nvCxnSpPr>
+          <p:cNvPr id="49" name="Conector: curvado 48">
+            <a:extLst>
+              <a:ext uri="{FF2B5EF4-FFF2-40B4-BE49-F238E27FC236}">
+                <a16:creationId xmlns:a16="http://schemas.microsoft.com/office/drawing/2014/main" id="{821F5E23-8539-9202-CA98-0CC8ADAEF0C8}"/>
+              </a:ext>
+            </a:extLst>
+          </p:cNvPr>
+          <p:cNvCxnSpPr>
+            <a:cxnSpLocks/>
+            <a:stCxn id="72" idx="1"/>
+            <a:endCxn id="38" idx="3"/>
+          </p:cNvCxnSpPr>
+          <p:nvPr/>
+        </p:nvCxnSpPr>
+        <p:spPr>
+          <a:xfrm rot="10800000">
+            <a:off x="4094367" y="2736059"/>
+            <a:ext cx="1986899" cy="1817862"/>
+          </a:xfrm>
+          <a:prstGeom prst="curvedConnector3">
+            <a:avLst>
+              <a:gd name="adj1" fmla="val 50000"/>
+            </a:avLst>
+          </a:prstGeom>
+          <a:ln>
+            <a:solidFill>
+              <a:schemeClr val="tx1">
+                <a:lumMod val="65000"/>
+                <a:lumOff val="35000"/>
+              </a:schemeClr>
+            </a:solidFill>
+            <a:prstDash val="dash"/>
+            <a:tailEnd type="triangle" w="lg" len="lg"/>
+          </a:ln>
+        </p:spPr>
+        <p:style>
+          <a:lnRef idx="2">
+            <a:schemeClr val="accent1"/>
+          </a:lnRef>
+          <a:fillRef idx="0">
+            <a:schemeClr val="accent1"/>
+          </a:fillRef>
+          <a:effectRef idx="1">
+            <a:schemeClr val="accent1"/>
+          </a:effectRef>
+          <a:fontRef idx="minor">
+            <a:schemeClr val="tx1"/>
+          </a:fontRef>
+        </p:style>
+      </p:cxnSp>
+      <p:grpSp>
+        <p:nvGrpSpPr>
+          <p:cNvPr id="54" name="Grupo 53">
+            <a:extLst>
+              <a:ext uri="{FF2B5EF4-FFF2-40B4-BE49-F238E27FC236}">
+                <a16:creationId xmlns:a16="http://schemas.microsoft.com/office/drawing/2014/main" id="{5889B6F9-1AEC-B0D9-D16F-34AA5FBECC6E}"/>
+              </a:ext>
+            </a:extLst>
+          </p:cNvPr>
+          <p:cNvGrpSpPr/>
+          <p:nvPr/>
+        </p:nvGrpSpPr>
+        <p:grpSpPr>
+          <a:xfrm>
+            <a:off x="6166148" y="2662621"/>
+            <a:ext cx="1872629" cy="2301269"/>
+            <a:chOff x="5159691" y="3311364"/>
+            <a:chExt cx="1872629" cy="2301269"/>
+          </a:xfrm>
+        </p:grpSpPr>
+        <p:sp>
+          <p:nvSpPr>
+            <p:cNvPr id="55" name="Rectángulo 54">
+              <a:extLst>
+                <a:ext uri="{FF2B5EF4-FFF2-40B4-BE49-F238E27FC236}">
+                  <a16:creationId xmlns:a16="http://schemas.microsoft.com/office/drawing/2014/main" id="{4D7A53B8-C44B-B9DE-BFBE-1CB4FF56D8AF}"/>
+                </a:ext>
+              </a:extLst>
+            </p:cNvPr>
+            <p:cNvSpPr/>
+            <p:nvPr/>
+          </p:nvSpPr>
+          <p:spPr>
+            <a:xfrm>
+              <a:off x="6164551" y="3311364"/>
+              <a:ext cx="627126" cy="882387"/>
+            </a:xfrm>
+            <a:prstGeom prst="rect">
+              <a:avLst/>
+            </a:prstGeom>
+            <a:solidFill>
+              <a:schemeClr val="bg2">
+                <a:lumMod val="90000"/>
+              </a:schemeClr>
+            </a:solidFill>
+          </p:spPr>
+          <p:style>
+            <a:lnRef idx="2">
+              <a:schemeClr val="accent1">
+                <a:shade val="15000"/>
+              </a:schemeClr>
+            </a:lnRef>
+            <a:fillRef idx="1">
+              <a:schemeClr val="accent1"/>
+            </a:fillRef>
+            <a:effectRef idx="0">
+              <a:schemeClr val="accent1"/>
+            </a:effectRef>
+            <a:fontRef idx="minor">
+              <a:schemeClr val="lt1"/>
+            </a:fontRef>
+          </p:style>
+          <p:txBody>
+            <a:bodyPr rtlCol="0" anchor="ctr"/>
+            <a:lstStyle/>
+            <a:p>
+              <a:pPr algn="ctr"/>
+              <a:endParaRPr lang="es-ES" dirty="0"/>
+            </a:p>
+          </p:txBody>
+        </p:sp>
+        <p:sp>
+          <p:nvSpPr>
+            <p:cNvPr id="56" name="Rectángulo 55">
+              <a:extLst>
+                <a:ext uri="{FF2B5EF4-FFF2-40B4-BE49-F238E27FC236}">
+                  <a16:creationId xmlns:a16="http://schemas.microsoft.com/office/drawing/2014/main" id="{FC5A868F-02D4-1A04-5955-6E09493CCEAC}"/>
+                </a:ext>
+              </a:extLst>
+            </p:cNvPr>
+            <p:cNvSpPr/>
+            <p:nvPr/>
+          </p:nvSpPr>
+          <p:spPr>
+            <a:xfrm>
+              <a:off x="6017856" y="3425738"/>
+              <a:ext cx="627126" cy="882387"/>
+            </a:xfrm>
+            <a:prstGeom prst="rect">
+              <a:avLst/>
+            </a:prstGeom>
+            <a:solidFill>
+              <a:schemeClr val="bg2">
+                <a:lumMod val="90000"/>
+              </a:schemeClr>
+            </a:solidFill>
+          </p:spPr>
+          <p:style>
+            <a:lnRef idx="2">
+              <a:schemeClr val="accent1">
+                <a:shade val="15000"/>
+              </a:schemeClr>
+            </a:lnRef>
+            <a:fillRef idx="1">
+              <a:schemeClr val="accent1"/>
+            </a:fillRef>
+            <a:effectRef idx="0">
+              <a:schemeClr val="accent1"/>
+            </a:effectRef>
+            <a:fontRef idx="minor">
+              <a:schemeClr val="lt1"/>
+            </a:fontRef>
+          </p:style>
+          <p:txBody>
+            <a:bodyPr rtlCol="0" anchor="ctr"/>
+            <a:lstStyle/>
+            <a:p>
+              <a:pPr algn="ctr"/>
+              <a:endParaRPr lang="es-ES" dirty="0"/>
+            </a:p>
+          </p:txBody>
+        </p:sp>
+        <p:grpSp>
+          <p:nvGrpSpPr>
+            <p:cNvPr id="57" name="Grupo 56">
+              <a:extLst>
+                <a:ext uri="{FF2B5EF4-FFF2-40B4-BE49-F238E27FC236}">
+                  <a16:creationId xmlns:a16="http://schemas.microsoft.com/office/drawing/2014/main" id="{9572215D-03AB-1E6D-C0A3-78B8F0E4FCB4}"/>
+                </a:ext>
+              </a:extLst>
+            </p:cNvPr>
+            <p:cNvGrpSpPr/>
+            <p:nvPr/>
+          </p:nvGrpSpPr>
+          <p:grpSpPr>
+            <a:xfrm>
+              <a:off x="5159691" y="3540112"/>
+              <a:ext cx="1872629" cy="2072521"/>
+              <a:chOff x="1754571" y="1307911"/>
+              <a:chExt cx="1872629" cy="2072521"/>
+            </a:xfrm>
+          </p:grpSpPr>
+          <p:grpSp>
+            <p:nvGrpSpPr>
+              <p:cNvPr id="58" name="Grupo 57">
+                <a:extLst>
+                  <a:ext uri="{FF2B5EF4-FFF2-40B4-BE49-F238E27FC236}">
+                    <a16:creationId xmlns:a16="http://schemas.microsoft.com/office/drawing/2014/main" id="{D9BD73F2-7D61-0FB0-D573-1A87E9E74D74}"/>
+                  </a:ext>
+                </a:extLst>
+              </p:cNvPr>
+              <p:cNvGrpSpPr/>
+              <p:nvPr/>
+            </p:nvGrpSpPr>
+            <p:grpSpPr>
+              <a:xfrm>
+                <a:off x="2288562" y="1307911"/>
+                <a:ext cx="804605" cy="882387"/>
+                <a:chOff x="2100116" y="1161875"/>
+                <a:chExt cx="1070929" cy="1174458"/>
+              </a:xfrm>
+            </p:grpSpPr>
+            <p:sp>
+              <p:nvSpPr>
+                <p:cNvPr id="60" name="Rectángulo 59">
+                  <a:extLst>
+                    <a:ext uri="{FF2B5EF4-FFF2-40B4-BE49-F238E27FC236}">
+                      <a16:creationId xmlns:a16="http://schemas.microsoft.com/office/drawing/2014/main" id="{65740583-2C14-FDAD-E131-4452ACEB7BF3}"/>
+                    </a:ext>
+                  </a:extLst>
+                </p:cNvPr>
+                <p:cNvSpPr/>
+                <p:nvPr/>
+              </p:nvSpPr>
+              <p:spPr>
+                <a:xfrm>
+                  <a:off x="2336341" y="1161875"/>
+                  <a:ext cx="834704" cy="1174458"/>
+                </a:xfrm>
+                <a:prstGeom prst="rect">
+                  <a:avLst/>
+                </a:prstGeom>
+                <a:solidFill>
+                  <a:schemeClr val="bg2">
+                    <a:lumMod val="90000"/>
+                  </a:schemeClr>
+                </a:solidFill>
+              </p:spPr>
+              <p:style>
+                <a:lnRef idx="2">
+                  <a:schemeClr val="accent1">
+                    <a:shade val="15000"/>
+                  </a:schemeClr>
+                </a:lnRef>
+                <a:fillRef idx="1">
+                  <a:schemeClr val="accent1"/>
+                </a:fillRef>
+                <a:effectRef idx="0">
+                  <a:schemeClr val="accent1"/>
+                </a:effectRef>
+                <a:fontRef idx="minor">
+                  <a:schemeClr val="lt1"/>
+                </a:fontRef>
+              </p:style>
+              <p:txBody>
+                <a:bodyPr rtlCol="0" anchor="ctr"/>
+                <a:lstStyle/>
+                <a:p>
+                  <a:pPr algn="ctr"/>
+                  <a:endParaRPr lang="es-ES"/>
+                </a:p>
+              </p:txBody>
+            </p:sp>
+            <p:sp>
+              <p:nvSpPr>
+                <p:cNvPr id="61" name="Elipse 60">
+                  <a:extLst>
+                    <a:ext uri="{FF2B5EF4-FFF2-40B4-BE49-F238E27FC236}">
+                      <a16:creationId xmlns:a16="http://schemas.microsoft.com/office/drawing/2014/main" id="{B6BD0955-0356-7677-1C57-F5EDF099E473}"/>
+                    </a:ext>
+                  </a:extLst>
+                </p:cNvPr>
+                <p:cNvSpPr/>
+                <p:nvPr/>
+              </p:nvSpPr>
+              <p:spPr>
+                <a:xfrm>
+                  <a:off x="2100116" y="1305718"/>
+                  <a:ext cx="644427" cy="211459"/>
+                </a:xfrm>
+                <a:prstGeom prst="ellipse">
+                  <a:avLst/>
+                </a:prstGeom>
+                <a:solidFill>
+                  <a:schemeClr val="bg1"/>
+                </a:solidFill>
+              </p:spPr>
+              <p:style>
+                <a:lnRef idx="2">
+                  <a:schemeClr val="accent1">
+                    <a:shade val="15000"/>
+                  </a:schemeClr>
+                </a:lnRef>
+                <a:fillRef idx="1">
+                  <a:schemeClr val="accent1"/>
+                </a:fillRef>
+                <a:effectRef idx="0">
+                  <a:schemeClr val="accent1"/>
+                </a:effectRef>
+                <a:fontRef idx="minor">
+                  <a:schemeClr val="lt1"/>
+                </a:fontRef>
+              </p:style>
+              <p:txBody>
+                <a:bodyPr rtlCol="0" anchor="ctr"/>
+                <a:lstStyle/>
+                <a:p>
+                  <a:pPr algn="ctr"/>
+                  <a:endParaRPr lang="es-ES"/>
+                </a:p>
+              </p:txBody>
+            </p:sp>
+            <p:sp>
+              <p:nvSpPr>
+                <p:cNvPr id="62" name="Rectángulo 61">
+                  <a:extLst>
+                    <a:ext uri="{FF2B5EF4-FFF2-40B4-BE49-F238E27FC236}">
+                      <a16:creationId xmlns:a16="http://schemas.microsoft.com/office/drawing/2014/main" id="{968CDFE7-3551-2098-2873-81A2723B2C49}"/>
+                    </a:ext>
+                  </a:extLst>
+                </p:cNvPr>
+                <p:cNvSpPr/>
+                <p:nvPr/>
+              </p:nvSpPr>
+              <p:spPr>
+                <a:xfrm>
+                  <a:off x="2100116" y="1639180"/>
+                  <a:ext cx="644427" cy="211459"/>
+                </a:xfrm>
+                <a:prstGeom prst="rect">
+                  <a:avLst/>
+                </a:prstGeom>
+                <a:solidFill>
+                  <a:schemeClr val="bg1"/>
+                </a:solidFill>
+              </p:spPr>
+              <p:style>
+                <a:lnRef idx="2">
+                  <a:schemeClr val="accent1">
+                    <a:shade val="15000"/>
+                  </a:schemeClr>
+                </a:lnRef>
+                <a:fillRef idx="1">
+                  <a:schemeClr val="accent1"/>
+                </a:fillRef>
+                <a:effectRef idx="0">
+                  <a:schemeClr val="accent1"/>
+                </a:effectRef>
+                <a:fontRef idx="minor">
+                  <a:schemeClr val="lt1"/>
+                </a:fontRef>
+              </p:style>
+              <p:txBody>
+                <a:bodyPr rtlCol="0" anchor="ctr"/>
+                <a:lstStyle/>
+                <a:p>
+                  <a:pPr algn="ctr"/>
+                  <a:endParaRPr lang="es-ES"/>
+                </a:p>
+              </p:txBody>
+            </p:sp>
+            <p:sp>
+              <p:nvSpPr>
+                <p:cNvPr id="63" name="Rectángulo 62">
+                  <a:extLst>
+                    <a:ext uri="{FF2B5EF4-FFF2-40B4-BE49-F238E27FC236}">
+                      <a16:creationId xmlns:a16="http://schemas.microsoft.com/office/drawing/2014/main" id="{6EBAA2FE-C677-0368-C2EB-670E8AE7E8BF}"/>
+                    </a:ext>
+                  </a:extLst>
+                </p:cNvPr>
+                <p:cNvSpPr/>
+                <p:nvPr/>
+              </p:nvSpPr>
+              <p:spPr>
+                <a:xfrm>
+                  <a:off x="2100116" y="1972642"/>
+                  <a:ext cx="644427" cy="211459"/>
+                </a:xfrm>
+                <a:prstGeom prst="rect">
+                  <a:avLst/>
+                </a:prstGeom>
+                <a:solidFill>
+                  <a:schemeClr val="bg1"/>
+                </a:solidFill>
+              </p:spPr>
+              <p:style>
+                <a:lnRef idx="2">
+                  <a:schemeClr val="accent1">
+                    <a:shade val="15000"/>
+                  </a:schemeClr>
+                </a:lnRef>
+                <a:fillRef idx="1">
+                  <a:schemeClr val="accent1"/>
+                </a:fillRef>
+                <a:effectRef idx="0">
+                  <a:schemeClr val="accent1"/>
+                </a:effectRef>
+                <a:fontRef idx="minor">
+                  <a:schemeClr val="lt1"/>
+                </a:fontRef>
+              </p:style>
+              <p:txBody>
+                <a:bodyPr rtlCol="0" anchor="ctr"/>
+                <a:lstStyle/>
+                <a:p>
+                  <a:pPr algn="ctr"/>
+                  <a:endParaRPr lang="es-ES"/>
+                </a:p>
+              </p:txBody>
+            </p:sp>
+          </p:grpSp>
+          <p:sp>
+            <p:nvSpPr>
+              <p:cNvPr id="59" name="CuadroTexto 58">
+                <a:extLst>
+                  <a:ext uri="{FF2B5EF4-FFF2-40B4-BE49-F238E27FC236}">
+                    <a16:creationId xmlns:a16="http://schemas.microsoft.com/office/drawing/2014/main" id="{221FABC8-F7D3-E0FB-07D6-878A5224B8A9}"/>
+                  </a:ext>
+                </a:extLst>
+              </p:cNvPr>
+              <p:cNvSpPr txBox="1"/>
+              <p:nvPr/>
+            </p:nvSpPr>
+            <p:spPr>
+              <a:xfrm>
+                <a:off x="1754571" y="2210881"/>
+                <a:ext cx="1872629" cy="1169551"/>
+              </a:xfrm>
+              <a:prstGeom prst="rect">
+                <a:avLst/>
+              </a:prstGeom>
+              <a:noFill/>
+            </p:spPr>
+            <p:txBody>
+              <a:bodyPr wrap="none" rtlCol="0">
+                <a:spAutoFit/>
+              </a:bodyPr>
+              <a:lstStyle/>
+              <a:p>
+                <a:pPr algn="ctr"/>
+                <a:r>
+                  <a:rPr lang="es-ES" sz="1400" dirty="0" err="1">
+                    <a:latin typeface="+mj-lt"/>
+                  </a:rPr>
+                  <a:t>core</a:t>
+                </a:r>
+                <a:r>
+                  <a:rPr lang="es-ES" sz="1400" dirty="0">
+                    <a:latin typeface="+mj-lt"/>
+                  </a:rPr>
+                  <a:t>/utilities.xsl</a:t>
+                </a:r>
+              </a:p>
+              <a:p>
+                <a:pPr algn="ctr"/>
+                <a:r>
+                  <a:rPr lang="es-ES" sz="1400" dirty="0" err="1">
+                    <a:latin typeface="+mj-lt"/>
+                  </a:rPr>
+                  <a:t>core</a:t>
+                </a:r>
+                <a:r>
+                  <a:rPr lang="es-ES" sz="1400" dirty="0">
+                    <a:latin typeface="+mj-lt"/>
+                  </a:rPr>
+                  <a:t>/properties.xsl</a:t>
+                </a:r>
+              </a:p>
+              <a:p>
+                <a:pPr algn="ctr"/>
+                <a:r>
+                  <a:rPr lang="es-ES" sz="1400" dirty="0" err="1">
+                    <a:latin typeface="+mj-lt"/>
+                  </a:rPr>
+                  <a:t>core</a:t>
+                </a:r>
+                <a:r>
+                  <a:rPr lang="es-ES" sz="1400" dirty="0">
+                    <a:latin typeface="+mj-lt"/>
+                  </a:rPr>
+                  <a:t>/document.xsl</a:t>
+                </a:r>
+              </a:p>
+              <a:p>
+                <a:pPr algn="ctr"/>
+                <a:r>
+                  <a:rPr lang="es-ES" sz="1400" dirty="0" err="1">
+                    <a:latin typeface="+mj-lt"/>
+                  </a:rPr>
+                  <a:t>core</a:t>
+                </a:r>
+                <a:r>
+                  <a:rPr lang="es-ES" sz="1400" dirty="0">
+                    <a:latin typeface="+mj-lt"/>
+                  </a:rPr>
+                  <a:t>/cover.xsl</a:t>
+                </a:r>
+              </a:p>
+              <a:p>
+                <a:pPr algn="ctr"/>
+                <a:r>
+                  <a:rPr lang="es-ES" sz="1400" dirty="0" err="1">
+                    <a:latin typeface="+mj-lt"/>
+                  </a:rPr>
+                  <a:t>core</a:t>
+                </a:r>
+                <a:r>
+                  <a:rPr lang="es-ES" sz="1400" dirty="0">
+                    <a:latin typeface="+mj-lt"/>
+                  </a:rPr>
+                  <a:t>/generate_table.xsl</a:t>
+                </a:r>
+              </a:p>
+            </p:txBody>
+          </p:sp>
+        </p:grpSp>
+      </p:grpSp>
+      <p:grpSp>
+        <p:nvGrpSpPr>
+          <p:cNvPr id="71" name="Grupo 70">
+            <a:extLst>
+              <a:ext uri="{FF2B5EF4-FFF2-40B4-BE49-F238E27FC236}">
+                <a16:creationId xmlns:a16="http://schemas.microsoft.com/office/drawing/2014/main" id="{C917BE6F-E08E-A67C-CB89-C79481764C32}"/>
+              </a:ext>
+            </a:extLst>
+          </p:cNvPr>
+          <p:cNvGrpSpPr/>
+          <p:nvPr/>
+        </p:nvGrpSpPr>
+        <p:grpSpPr>
+          <a:xfrm>
+            <a:off x="7484571" y="2109665"/>
+            <a:ext cx="1416196" cy="552956"/>
+            <a:chOff x="7484571" y="2109665"/>
+            <a:chExt cx="1416196" cy="552956"/>
+          </a:xfrm>
+        </p:grpSpPr>
+        <p:cxnSp>
+          <p:nvCxnSpPr>
+            <p:cNvPr id="50" name="Conector recto de flecha 49">
+              <a:extLst>
+                <a:ext uri="{FF2B5EF4-FFF2-40B4-BE49-F238E27FC236}">
+                  <a16:creationId xmlns:a16="http://schemas.microsoft.com/office/drawing/2014/main" id="{328DDAB2-92C6-A9F9-3215-93E3D4B3644C}"/>
+                </a:ext>
+              </a:extLst>
+            </p:cNvPr>
+            <p:cNvCxnSpPr>
+              <a:cxnSpLocks/>
+              <a:stCxn id="21" idx="2"/>
+              <a:endCxn id="55" idx="0"/>
+            </p:cNvCxnSpPr>
+            <p:nvPr/>
+          </p:nvCxnSpPr>
+          <p:spPr>
+            <a:xfrm flipH="1">
+              <a:off x="7484571" y="2109665"/>
+              <a:ext cx="1416196" cy="552956"/>
+            </a:xfrm>
+            <a:prstGeom prst="straightConnector1">
+              <a:avLst/>
+            </a:prstGeom>
+            <a:ln>
+              <a:solidFill>
+                <a:schemeClr val="tx1">
+                  <a:lumMod val="65000"/>
+                  <a:lumOff val="35000"/>
+                </a:schemeClr>
+              </a:solidFill>
+              <a:prstDash val="solid"/>
+              <a:tailEnd type="triangle" w="lg" len="lg"/>
+            </a:ln>
+          </p:spPr>
+          <p:style>
+            <a:lnRef idx="2">
+              <a:schemeClr val="accent1"/>
+            </a:lnRef>
+            <a:fillRef idx="0">
+              <a:schemeClr val="accent1"/>
+            </a:fillRef>
+            <a:effectRef idx="1">
+              <a:schemeClr val="accent1"/>
+            </a:effectRef>
+            <a:fontRef idx="minor">
+              <a:schemeClr val="tx1"/>
+            </a:fontRef>
+          </p:style>
+        </p:cxnSp>
+        <p:sp>
+          <p:nvSpPr>
+            <p:cNvPr id="70" name="CuadroTexto 69">
+              <a:extLst>
+                <a:ext uri="{FF2B5EF4-FFF2-40B4-BE49-F238E27FC236}">
+                  <a16:creationId xmlns:a16="http://schemas.microsoft.com/office/drawing/2014/main" id="{BEFB851F-43A8-047E-2157-F87421F9375F}"/>
+                </a:ext>
+              </a:extLst>
+            </p:cNvPr>
+            <p:cNvSpPr txBox="1"/>
+            <p:nvPr/>
+          </p:nvSpPr>
+          <p:spPr>
+            <a:xfrm rot="20315626">
+              <a:off x="7564057" y="2114313"/>
+              <a:ext cx="1032655" cy="276999"/>
+            </a:xfrm>
+            <a:prstGeom prst="rect">
+              <a:avLst/>
+            </a:prstGeom>
+            <a:noFill/>
+          </p:spPr>
+          <p:txBody>
+            <a:bodyPr wrap="none" rtlCol="0">
+              <a:spAutoFit/>
+            </a:bodyPr>
+            <a:lstStyle/>
+            <a:p>
+              <a:r>
+                <a:rPr lang="es-ES" sz="1200" dirty="0"/>
+                <a:t>«</a:t>
+              </a:r>
+              <a:r>
+                <a:rPr lang="es-ES" sz="1200" dirty="0" err="1"/>
+                <a:t>includes</a:t>
+              </a:r>
+              <a:r>
+                <a:rPr lang="es-ES" sz="1200" dirty="0"/>
+                <a:t>» ①</a:t>
+              </a:r>
+            </a:p>
+          </p:txBody>
+        </p:sp>
+      </p:grpSp>
+      <p:sp>
+        <p:nvSpPr>
+          <p:cNvPr id="73" name="CuadroTexto 72">
+            <a:extLst>
+              <a:ext uri="{FF2B5EF4-FFF2-40B4-BE49-F238E27FC236}">
+                <a16:creationId xmlns:a16="http://schemas.microsoft.com/office/drawing/2014/main" id="{9C2827AE-E203-1635-7317-C25AE6890CA5}"/>
+              </a:ext>
+            </a:extLst>
+          </p:cNvPr>
+          <p:cNvSpPr txBox="1"/>
+          <p:nvPr/>
+        </p:nvSpPr>
+        <p:spPr>
+          <a:xfrm rot="3077395">
+            <a:off x="4781436" y="3186393"/>
+            <a:ext cx="928459" cy="276999"/>
+          </a:xfrm>
+          <a:prstGeom prst="rect">
+            <a:avLst/>
+          </a:prstGeom>
+          <a:noFill/>
+        </p:spPr>
+        <p:txBody>
+          <a:bodyPr wrap="none" rtlCol="0">
+            <a:spAutoFit/>
+          </a:bodyPr>
+          <a:lstStyle/>
+          <a:p>
+            <a:r>
+              <a:rPr lang="es-ES" sz="1200" dirty="0"/>
+              <a:t>«</a:t>
+            </a:r>
+            <a:r>
+              <a:rPr lang="es-ES" sz="1200" dirty="0" err="1"/>
+              <a:t>depends</a:t>
+            </a:r>
+            <a:r>
+              <a:rPr lang="es-ES" sz="1200" dirty="0"/>
+              <a:t>»</a:t>
+            </a:r>
+          </a:p>
+        </p:txBody>
+      </p:sp>
+      <p:grpSp>
+        <p:nvGrpSpPr>
+          <p:cNvPr id="74" name="Grupo 73">
+            <a:extLst>
+              <a:ext uri="{FF2B5EF4-FFF2-40B4-BE49-F238E27FC236}">
+                <a16:creationId xmlns:a16="http://schemas.microsoft.com/office/drawing/2014/main" id="{955C6189-4372-F8ED-D1BE-EF699FA5E0C6}"/>
+              </a:ext>
+            </a:extLst>
+          </p:cNvPr>
+          <p:cNvGrpSpPr/>
+          <p:nvPr/>
+        </p:nvGrpSpPr>
+        <p:grpSpPr>
+          <a:xfrm>
+            <a:off x="8566803" y="2681538"/>
+            <a:ext cx="3426579" cy="4024818"/>
+            <a:chOff x="4382720" y="3311364"/>
+            <a:chExt cx="3426579" cy="4024818"/>
+          </a:xfrm>
+        </p:grpSpPr>
+        <p:sp>
+          <p:nvSpPr>
+            <p:cNvPr id="75" name="Rectángulo 74">
+              <a:extLst>
+                <a:ext uri="{FF2B5EF4-FFF2-40B4-BE49-F238E27FC236}">
+                  <a16:creationId xmlns:a16="http://schemas.microsoft.com/office/drawing/2014/main" id="{E19B3048-7FCA-60AE-F534-48EFD4940616}"/>
+                </a:ext>
+              </a:extLst>
+            </p:cNvPr>
+            <p:cNvSpPr/>
+            <p:nvPr/>
+          </p:nvSpPr>
+          <p:spPr>
+            <a:xfrm>
+              <a:off x="6164551" y="3311364"/>
+              <a:ext cx="627126" cy="882387"/>
+            </a:xfrm>
+            <a:prstGeom prst="rect">
+              <a:avLst/>
+            </a:prstGeom>
+            <a:solidFill>
+              <a:schemeClr val="bg2">
+                <a:lumMod val="90000"/>
+              </a:schemeClr>
+            </a:solidFill>
+          </p:spPr>
+          <p:style>
+            <a:lnRef idx="2">
+              <a:schemeClr val="accent1">
+                <a:shade val="15000"/>
+              </a:schemeClr>
+            </a:lnRef>
+            <a:fillRef idx="1">
+              <a:schemeClr val="accent1"/>
+            </a:fillRef>
+            <a:effectRef idx="0">
+              <a:schemeClr val="accent1"/>
+            </a:effectRef>
+            <a:fontRef idx="minor">
+              <a:schemeClr val="lt1"/>
+            </a:fontRef>
+          </p:style>
+          <p:txBody>
+            <a:bodyPr rtlCol="0" anchor="ctr"/>
+            <a:lstStyle/>
+            <a:p>
+              <a:pPr algn="ctr"/>
+              <a:endParaRPr lang="es-ES" dirty="0"/>
+            </a:p>
+          </p:txBody>
+        </p:sp>
+        <p:sp>
+          <p:nvSpPr>
+            <p:cNvPr id="76" name="Rectángulo 75">
+              <a:extLst>
+                <a:ext uri="{FF2B5EF4-FFF2-40B4-BE49-F238E27FC236}">
+                  <a16:creationId xmlns:a16="http://schemas.microsoft.com/office/drawing/2014/main" id="{3E26D2C9-888E-F5CC-3204-D4FABB6B2198}"/>
+                </a:ext>
+              </a:extLst>
+            </p:cNvPr>
+            <p:cNvSpPr/>
+            <p:nvPr/>
+          </p:nvSpPr>
+          <p:spPr>
+            <a:xfrm>
+              <a:off x="6017856" y="3425738"/>
+              <a:ext cx="627126" cy="882387"/>
+            </a:xfrm>
+            <a:prstGeom prst="rect">
+              <a:avLst/>
+            </a:prstGeom>
+            <a:solidFill>
+              <a:schemeClr val="bg2">
+                <a:lumMod val="90000"/>
+              </a:schemeClr>
+            </a:solidFill>
+          </p:spPr>
+          <p:style>
+            <a:lnRef idx="2">
+              <a:schemeClr val="accent1">
+                <a:shade val="15000"/>
+              </a:schemeClr>
+            </a:lnRef>
+            <a:fillRef idx="1">
+              <a:schemeClr val="accent1"/>
+            </a:fillRef>
+            <a:effectRef idx="0">
+              <a:schemeClr val="accent1"/>
+            </a:effectRef>
+            <a:fontRef idx="minor">
+              <a:schemeClr val="lt1"/>
+            </a:fontRef>
+          </p:style>
+          <p:txBody>
+            <a:bodyPr rtlCol="0" anchor="ctr"/>
+            <a:lstStyle/>
+            <a:p>
+              <a:pPr algn="ctr"/>
+              <a:endParaRPr lang="es-ES" dirty="0"/>
+            </a:p>
+          </p:txBody>
+        </p:sp>
+        <p:grpSp>
+          <p:nvGrpSpPr>
+            <p:cNvPr id="77" name="Grupo 76">
+              <a:extLst>
+                <a:ext uri="{FF2B5EF4-FFF2-40B4-BE49-F238E27FC236}">
+                  <a16:creationId xmlns:a16="http://schemas.microsoft.com/office/drawing/2014/main" id="{8483880C-C829-C32F-2776-729626023AD2}"/>
+                </a:ext>
+              </a:extLst>
+            </p:cNvPr>
+            <p:cNvGrpSpPr/>
+            <p:nvPr/>
+          </p:nvGrpSpPr>
+          <p:grpSpPr>
+            <a:xfrm>
+              <a:off x="4382720" y="3540112"/>
+              <a:ext cx="3426579" cy="3796070"/>
+              <a:chOff x="977600" y="1307911"/>
+              <a:chExt cx="3426579" cy="3796070"/>
+            </a:xfrm>
+          </p:grpSpPr>
+          <p:grpSp>
+            <p:nvGrpSpPr>
+              <p:cNvPr id="78" name="Grupo 77">
+                <a:extLst>
+                  <a:ext uri="{FF2B5EF4-FFF2-40B4-BE49-F238E27FC236}">
+                    <a16:creationId xmlns:a16="http://schemas.microsoft.com/office/drawing/2014/main" id="{314BE961-ACEC-EA60-C233-A576F57683F9}"/>
+                  </a:ext>
+                </a:extLst>
+              </p:cNvPr>
+              <p:cNvGrpSpPr/>
+              <p:nvPr/>
+            </p:nvGrpSpPr>
+            <p:grpSpPr>
+              <a:xfrm>
+                <a:off x="2288562" y="1307911"/>
+                <a:ext cx="804605" cy="882387"/>
+                <a:chOff x="2100116" y="1161875"/>
+                <a:chExt cx="1070929" cy="1174458"/>
+              </a:xfrm>
+            </p:grpSpPr>
+            <p:sp>
+              <p:nvSpPr>
+                <p:cNvPr id="80" name="Rectángulo 79">
+                  <a:extLst>
+                    <a:ext uri="{FF2B5EF4-FFF2-40B4-BE49-F238E27FC236}">
+                      <a16:creationId xmlns:a16="http://schemas.microsoft.com/office/drawing/2014/main" id="{9012019E-BAE7-DF73-2FBA-1AC286F824E6}"/>
+                    </a:ext>
+                  </a:extLst>
+                </p:cNvPr>
+                <p:cNvSpPr/>
+                <p:nvPr/>
+              </p:nvSpPr>
+              <p:spPr>
+                <a:xfrm>
+                  <a:off x="2336341" y="1161875"/>
+                  <a:ext cx="834704" cy="1174458"/>
+                </a:xfrm>
+                <a:prstGeom prst="rect">
+                  <a:avLst/>
+                </a:prstGeom>
+                <a:solidFill>
+                  <a:schemeClr val="bg2">
+                    <a:lumMod val="90000"/>
+                  </a:schemeClr>
+                </a:solidFill>
+              </p:spPr>
+              <p:style>
+                <a:lnRef idx="2">
+                  <a:schemeClr val="accent1">
+                    <a:shade val="15000"/>
+                  </a:schemeClr>
+                </a:lnRef>
+                <a:fillRef idx="1">
+                  <a:schemeClr val="accent1"/>
+                </a:fillRef>
+                <a:effectRef idx="0">
+                  <a:schemeClr val="accent1"/>
+                </a:effectRef>
+                <a:fontRef idx="minor">
+                  <a:schemeClr val="lt1"/>
+                </a:fontRef>
+              </p:style>
+              <p:txBody>
+                <a:bodyPr rtlCol="0" anchor="ctr"/>
+                <a:lstStyle/>
+                <a:p>
+                  <a:pPr algn="ctr"/>
+                  <a:endParaRPr lang="es-ES"/>
+                </a:p>
+              </p:txBody>
+            </p:sp>
+            <p:sp>
+              <p:nvSpPr>
+                <p:cNvPr id="81" name="Elipse 80">
+                  <a:extLst>
+                    <a:ext uri="{FF2B5EF4-FFF2-40B4-BE49-F238E27FC236}">
+                      <a16:creationId xmlns:a16="http://schemas.microsoft.com/office/drawing/2014/main" id="{FEE7866C-230B-7483-72E9-5C76973BE031}"/>
+                    </a:ext>
+                  </a:extLst>
+                </p:cNvPr>
+                <p:cNvSpPr/>
+                <p:nvPr/>
+              </p:nvSpPr>
+              <p:spPr>
+                <a:xfrm>
+                  <a:off x="2100116" y="1305718"/>
+                  <a:ext cx="644427" cy="211459"/>
+                </a:xfrm>
+                <a:prstGeom prst="ellipse">
+                  <a:avLst/>
+                </a:prstGeom>
+                <a:solidFill>
+                  <a:schemeClr val="bg1"/>
+                </a:solidFill>
+              </p:spPr>
+              <p:style>
+                <a:lnRef idx="2">
+                  <a:schemeClr val="accent1">
+                    <a:shade val="15000"/>
+                  </a:schemeClr>
+                </a:lnRef>
+                <a:fillRef idx="1">
+                  <a:schemeClr val="accent1"/>
+                </a:fillRef>
+                <a:effectRef idx="0">
+                  <a:schemeClr val="accent1"/>
+                </a:effectRef>
+                <a:fontRef idx="minor">
+                  <a:schemeClr val="lt1"/>
+                </a:fontRef>
+              </p:style>
+              <p:txBody>
+                <a:bodyPr rtlCol="0" anchor="ctr"/>
+                <a:lstStyle/>
+                <a:p>
+                  <a:pPr algn="ctr"/>
+                  <a:endParaRPr lang="es-ES"/>
+                </a:p>
+              </p:txBody>
+            </p:sp>
+            <p:sp>
+              <p:nvSpPr>
+                <p:cNvPr id="82" name="Rectángulo 81">
+                  <a:extLst>
+                    <a:ext uri="{FF2B5EF4-FFF2-40B4-BE49-F238E27FC236}">
+                      <a16:creationId xmlns:a16="http://schemas.microsoft.com/office/drawing/2014/main" id="{35E089A1-1513-F172-0FFC-BDE820D20B82}"/>
+                    </a:ext>
+                  </a:extLst>
+                </p:cNvPr>
+                <p:cNvSpPr/>
+                <p:nvPr/>
+              </p:nvSpPr>
+              <p:spPr>
+                <a:xfrm>
+                  <a:off x="2100116" y="1639180"/>
+                  <a:ext cx="644427" cy="211459"/>
+                </a:xfrm>
+                <a:prstGeom prst="rect">
+                  <a:avLst/>
+                </a:prstGeom>
+                <a:solidFill>
+                  <a:schemeClr val="bg1"/>
+                </a:solidFill>
+              </p:spPr>
+              <p:style>
+                <a:lnRef idx="2">
+                  <a:schemeClr val="accent1">
+                    <a:shade val="15000"/>
+                  </a:schemeClr>
+                </a:lnRef>
+                <a:fillRef idx="1">
+                  <a:schemeClr val="accent1"/>
+                </a:fillRef>
+                <a:effectRef idx="0">
+                  <a:schemeClr val="accent1"/>
+                </a:effectRef>
+                <a:fontRef idx="minor">
+                  <a:schemeClr val="lt1"/>
+                </a:fontRef>
+              </p:style>
+              <p:txBody>
+                <a:bodyPr rtlCol="0" anchor="ctr"/>
+                <a:lstStyle/>
+                <a:p>
+                  <a:pPr algn="ctr"/>
+                  <a:endParaRPr lang="es-ES"/>
+                </a:p>
+              </p:txBody>
+            </p:sp>
+            <p:sp>
+              <p:nvSpPr>
+                <p:cNvPr id="83" name="Rectángulo 82">
+                  <a:extLst>
+                    <a:ext uri="{FF2B5EF4-FFF2-40B4-BE49-F238E27FC236}">
+                      <a16:creationId xmlns:a16="http://schemas.microsoft.com/office/drawing/2014/main" id="{255093A2-491E-1A4F-A91F-985BE636CD2C}"/>
+                    </a:ext>
+                  </a:extLst>
+                </p:cNvPr>
+                <p:cNvSpPr/>
+                <p:nvPr/>
+              </p:nvSpPr>
+              <p:spPr>
+                <a:xfrm>
+                  <a:off x="2100116" y="1972642"/>
+                  <a:ext cx="644427" cy="211459"/>
+                </a:xfrm>
+                <a:prstGeom prst="rect">
+                  <a:avLst/>
+                </a:prstGeom>
+                <a:solidFill>
+                  <a:schemeClr val="bg1"/>
+                </a:solidFill>
+              </p:spPr>
+              <p:style>
+                <a:lnRef idx="2">
+                  <a:schemeClr val="accent1">
+                    <a:shade val="15000"/>
+                  </a:schemeClr>
+                </a:lnRef>
+                <a:fillRef idx="1">
+                  <a:schemeClr val="accent1"/>
+                </a:fillRef>
+                <a:effectRef idx="0">
+                  <a:schemeClr val="accent1"/>
+                </a:effectRef>
+                <a:fontRef idx="minor">
+                  <a:schemeClr val="lt1"/>
+                </a:fontRef>
+              </p:style>
+              <p:txBody>
+                <a:bodyPr rtlCol="0" anchor="ctr"/>
+                <a:lstStyle/>
+                <a:p>
+                  <a:pPr algn="ctr"/>
+                  <a:endParaRPr lang="es-ES"/>
+                </a:p>
+              </p:txBody>
+            </p:sp>
+          </p:grpSp>
+          <p:sp>
+            <p:nvSpPr>
+              <p:cNvPr id="79" name="CuadroTexto 78">
+                <a:extLst>
+                  <a:ext uri="{FF2B5EF4-FFF2-40B4-BE49-F238E27FC236}">
+                    <a16:creationId xmlns:a16="http://schemas.microsoft.com/office/drawing/2014/main" id="{71FEEEF7-E5AD-5BCC-DECF-20E88DA101D0}"/>
+                  </a:ext>
+                </a:extLst>
+              </p:cNvPr>
+              <p:cNvSpPr txBox="1"/>
+              <p:nvPr/>
+            </p:nvSpPr>
+            <p:spPr>
+              <a:xfrm>
+                <a:off x="977600" y="2210881"/>
+                <a:ext cx="3426579" cy="2893100"/>
+              </a:xfrm>
+              <a:prstGeom prst="rect">
+                <a:avLst/>
+              </a:prstGeom>
+              <a:noFill/>
+            </p:spPr>
+            <p:txBody>
+              <a:bodyPr wrap="none" rtlCol="0">
+                <a:spAutoFit/>
+              </a:bodyPr>
+              <a:lstStyle/>
+              <a:p>
+                <a:pPr algn="ctr"/>
+                <a:r>
+                  <a:rPr lang="es-ES" sz="1400" dirty="0" err="1">
+                    <a:latin typeface="+mj-lt"/>
+                  </a:rPr>
+                  <a:t>archetypes</a:t>
+                </a:r>
+                <a:r>
+                  <a:rPr lang="es-ES" sz="1400" dirty="0">
+                    <a:latin typeface="+mj-lt"/>
+                  </a:rPr>
+                  <a:t>/general/section.xsl</a:t>
+                </a:r>
+              </a:p>
+              <a:p>
+                <a:pPr algn="ctr"/>
+                <a:r>
+                  <a:rPr lang="es-ES" sz="1400" dirty="0" err="1"/>
+                  <a:t>archetypes</a:t>
+                </a:r>
+                <a:r>
+                  <a:rPr lang="es-ES" sz="1400" dirty="0"/>
+                  <a:t>/general</a:t>
+                </a:r>
+                <a:r>
+                  <a:rPr lang="es-ES" sz="1400" dirty="0">
+                    <a:latin typeface="+mj-lt"/>
+                  </a:rPr>
+                  <a:t>/appendix.xsl</a:t>
+                </a:r>
+              </a:p>
+              <a:p>
+                <a:pPr algn="ctr"/>
+                <a:r>
+                  <a:rPr lang="es-ES" sz="1400" dirty="0" err="1"/>
+                  <a:t>archetypes</a:t>
+                </a:r>
+                <a:r>
+                  <a:rPr lang="es-ES" sz="1400" dirty="0"/>
+                  <a:t>/general/</a:t>
+                </a:r>
+                <a:r>
+                  <a:rPr lang="es-ES" sz="1400" dirty="0">
+                    <a:latin typeface="+mj-lt"/>
+                  </a:rPr>
+                  <a:t>paragraph.xsl</a:t>
+                </a:r>
+              </a:p>
+              <a:p>
+                <a:pPr algn="ctr"/>
+                <a:r>
+                  <a:rPr lang="es-ES" sz="1400" dirty="0" err="1"/>
+                  <a:t>archetypes</a:t>
+                </a:r>
+                <a:r>
+                  <a:rPr lang="es-ES" sz="1400" dirty="0"/>
+                  <a:t>/general/comment.xsl</a:t>
+                </a:r>
+                <a:endParaRPr lang="es-ES" sz="1400" dirty="0">
+                  <a:latin typeface="+mj-lt"/>
+                </a:endParaRPr>
+              </a:p>
+              <a:p>
+                <a:pPr algn="ctr"/>
+                <a:r>
+                  <a:rPr lang="es-ES" sz="1400" dirty="0" err="1"/>
+                  <a:t>archetypes</a:t>
+                </a:r>
+                <a:r>
+                  <a:rPr lang="es-ES" sz="1400" dirty="0"/>
+                  <a:t>/general/</a:t>
+                </a:r>
+                <a:r>
+                  <a:rPr lang="es-ES" sz="1400" dirty="0">
+                    <a:latin typeface="+mj-lt"/>
+                  </a:rPr>
+                  <a:t>glossary_item.xsl</a:t>
+                </a:r>
+              </a:p>
+              <a:p>
+                <a:pPr algn="ctr"/>
+                <a:r>
+                  <a:rPr lang="es-ES" sz="1400" dirty="0" err="1"/>
+                  <a:t>archetypes</a:t>
+                </a:r>
+                <a:r>
+                  <a:rPr lang="es-ES" sz="1400" dirty="0"/>
+                  <a:t>/general/bibliography_item.xsl</a:t>
+                </a:r>
+              </a:p>
+              <a:p>
+                <a:pPr algn="ctr"/>
+                <a:r>
+                  <a:rPr lang="es-ES" sz="1400" dirty="0" err="1"/>
+                  <a:t>archetypes</a:t>
+                </a:r>
+                <a:r>
+                  <a:rPr lang="es-ES" sz="1400" dirty="0"/>
+                  <a:t>/general/figure.xsl</a:t>
+                </a:r>
+              </a:p>
+              <a:p>
+                <a:pPr algn="ctr"/>
+                <a:r>
+                  <a:rPr lang="es-ES" sz="1400" dirty="0" err="1"/>
+                  <a:t>archetypes</a:t>
+                </a:r>
+                <a:r>
+                  <a:rPr lang="es-ES" sz="1400" dirty="0"/>
+                  <a:t>/general/organization.xsl</a:t>
+                </a:r>
+              </a:p>
+              <a:p>
+                <a:pPr algn="ctr"/>
+                <a:r>
+                  <a:rPr lang="es-ES" sz="1400" dirty="0" err="1"/>
+                  <a:t>archetypes</a:t>
+                </a:r>
+                <a:r>
+                  <a:rPr lang="es-ES" sz="1400" dirty="0"/>
+                  <a:t>/general/stakeholder.xsl</a:t>
+                </a:r>
+              </a:p>
+              <a:p>
+                <a:pPr algn="ctr"/>
+                <a:r>
+                  <a:rPr lang="es-ES" sz="1400" dirty="0" err="1"/>
+                  <a:t>archetypes</a:t>
+                </a:r>
+                <a:r>
+                  <a:rPr lang="es-ES" sz="1400" dirty="0"/>
+                  <a:t>/general/meeting.xsl</a:t>
+                </a:r>
+              </a:p>
+              <a:p>
+                <a:pPr algn="ctr"/>
+                <a:r>
+                  <a:rPr lang="es-ES" sz="1400" dirty="0" err="1"/>
+                  <a:t>archetypes</a:t>
+                </a:r>
+                <a:r>
+                  <a:rPr lang="es-ES" sz="1400" dirty="0"/>
+                  <a:t>/general/traceability_matrix.xsl</a:t>
+                </a:r>
+              </a:p>
+              <a:p>
+                <a:pPr algn="ctr"/>
+                <a:r>
+                  <a:rPr lang="es-ES" sz="1400" dirty="0" err="1"/>
+                  <a:t>archetypes</a:t>
+                </a:r>
+                <a:r>
+                  <a:rPr lang="es-ES" sz="1400" dirty="0"/>
+                  <a:t>/general/symbolic_link.xsl</a:t>
+                </a:r>
+              </a:p>
+              <a:p>
+                <a:pPr algn="ctr"/>
+                <a:r>
+                  <a:rPr lang="es-ES" sz="1400" dirty="0" err="1"/>
+                  <a:t>archetypes</a:t>
+                </a:r>
+                <a:r>
+                  <a:rPr lang="es-ES" sz="1400" dirty="0"/>
+                  <a:t>/any_archetype.xsl</a:t>
+                </a:r>
+              </a:p>
+            </p:txBody>
+          </p:sp>
+        </p:grpSp>
+      </p:grpSp>
+      <p:sp>
+        <p:nvSpPr>
+          <p:cNvPr id="5" name="CuadroTexto 4">
+            <a:extLst>
+              <a:ext uri="{FF2B5EF4-FFF2-40B4-BE49-F238E27FC236}">
+                <a16:creationId xmlns:a16="http://schemas.microsoft.com/office/drawing/2014/main" id="{207BB250-4867-7F69-1018-FE4FF574B2AE}"/>
+              </a:ext>
+            </a:extLst>
+          </p:cNvPr>
+          <p:cNvSpPr txBox="1"/>
+          <p:nvPr/>
+        </p:nvSpPr>
+        <p:spPr>
+          <a:xfrm>
+            <a:off x="9287148" y="64832"/>
+            <a:ext cx="2849113" cy="369332"/>
+          </a:xfrm>
+          <a:prstGeom prst="rect">
+            <a:avLst/>
+          </a:prstGeom>
+          <a:noFill/>
+        </p:spPr>
+        <p:txBody>
+          <a:bodyPr wrap="none" rtlCol="0">
+            <a:spAutoFit/>
+          </a:bodyPr>
+          <a:lstStyle/>
+          <a:p>
+            <a:r>
+              <a:rPr lang="es-ES" b="1" dirty="0"/>
+              <a:t>Refactorizado por Claude</a:t>
+            </a:r>
+          </a:p>
+        </p:txBody>
+      </p:sp>
+      <p:grpSp>
+        <p:nvGrpSpPr>
+          <p:cNvPr id="17" name="Grupo 16">
+            <a:extLst>
+              <a:ext uri="{FF2B5EF4-FFF2-40B4-BE49-F238E27FC236}">
+                <a16:creationId xmlns:a16="http://schemas.microsoft.com/office/drawing/2014/main" id="{E4E2688F-7E16-8204-9668-A82E964A7BD2}"/>
+              </a:ext>
+            </a:extLst>
+          </p:cNvPr>
+          <p:cNvGrpSpPr/>
+          <p:nvPr/>
+        </p:nvGrpSpPr>
+        <p:grpSpPr>
+          <a:xfrm>
+            <a:off x="335515" y="1019565"/>
+            <a:ext cx="3758851" cy="2301269"/>
+            <a:chOff x="4216582" y="3311364"/>
+            <a:chExt cx="3758851" cy="2301269"/>
+          </a:xfrm>
+        </p:grpSpPr>
+        <p:sp>
+          <p:nvSpPr>
+            <p:cNvPr id="27" name="Rectángulo 26">
+              <a:extLst>
+                <a:ext uri="{FF2B5EF4-FFF2-40B4-BE49-F238E27FC236}">
+                  <a16:creationId xmlns:a16="http://schemas.microsoft.com/office/drawing/2014/main" id="{CA818AD5-7816-FADA-004B-6DE21B339E95}"/>
+                </a:ext>
+              </a:extLst>
+            </p:cNvPr>
+            <p:cNvSpPr/>
+            <p:nvPr/>
+          </p:nvSpPr>
+          <p:spPr>
+            <a:xfrm>
+              <a:off x="6164551" y="3311364"/>
+              <a:ext cx="627126" cy="882387"/>
+            </a:xfrm>
+            <a:prstGeom prst="rect">
+              <a:avLst/>
+            </a:prstGeom>
+            <a:solidFill>
+              <a:schemeClr val="bg2">
+                <a:lumMod val="90000"/>
+              </a:schemeClr>
+            </a:solidFill>
+          </p:spPr>
+          <p:style>
+            <a:lnRef idx="2">
+              <a:schemeClr val="accent1">
+                <a:shade val="15000"/>
+              </a:schemeClr>
+            </a:lnRef>
+            <a:fillRef idx="1">
+              <a:schemeClr val="accent1"/>
+            </a:fillRef>
+            <a:effectRef idx="0">
+              <a:schemeClr val="accent1"/>
+            </a:effectRef>
+            <a:fontRef idx="minor">
+              <a:schemeClr val="lt1"/>
+            </a:fontRef>
+          </p:style>
+          <p:txBody>
+            <a:bodyPr rtlCol="0" anchor="ctr"/>
+            <a:lstStyle/>
+            <a:p>
+              <a:pPr algn="ctr"/>
+              <a:endParaRPr lang="es-ES" dirty="0"/>
+            </a:p>
+          </p:txBody>
+        </p:sp>
+        <p:sp>
+          <p:nvSpPr>
+            <p:cNvPr id="28" name="Rectángulo 27">
+              <a:extLst>
+                <a:ext uri="{FF2B5EF4-FFF2-40B4-BE49-F238E27FC236}">
+                  <a16:creationId xmlns:a16="http://schemas.microsoft.com/office/drawing/2014/main" id="{B3609B64-684E-7F2F-028B-3A22E535A19D}"/>
+                </a:ext>
+              </a:extLst>
+            </p:cNvPr>
+            <p:cNvSpPr/>
+            <p:nvPr/>
+          </p:nvSpPr>
+          <p:spPr>
+            <a:xfrm>
+              <a:off x="6017856" y="3425738"/>
+              <a:ext cx="627126" cy="882387"/>
+            </a:xfrm>
+            <a:prstGeom prst="rect">
+              <a:avLst/>
+            </a:prstGeom>
+            <a:solidFill>
+              <a:schemeClr val="bg2">
+                <a:lumMod val="90000"/>
+              </a:schemeClr>
+            </a:solidFill>
+          </p:spPr>
+          <p:style>
+            <a:lnRef idx="2">
+              <a:schemeClr val="accent1">
+                <a:shade val="15000"/>
+              </a:schemeClr>
+            </a:lnRef>
+            <a:fillRef idx="1">
+              <a:schemeClr val="accent1"/>
+            </a:fillRef>
+            <a:effectRef idx="0">
+              <a:schemeClr val="accent1"/>
+            </a:effectRef>
+            <a:fontRef idx="minor">
+              <a:schemeClr val="lt1"/>
+            </a:fontRef>
+          </p:style>
+          <p:txBody>
+            <a:bodyPr rtlCol="0" anchor="ctr"/>
+            <a:lstStyle/>
+            <a:p>
+              <a:pPr algn="ctr"/>
+              <a:endParaRPr lang="es-ES" dirty="0"/>
+            </a:p>
+          </p:txBody>
+        </p:sp>
+        <p:grpSp>
+          <p:nvGrpSpPr>
+            <p:cNvPr id="29" name="Grupo 28">
+              <a:extLst>
+                <a:ext uri="{FF2B5EF4-FFF2-40B4-BE49-F238E27FC236}">
+                  <a16:creationId xmlns:a16="http://schemas.microsoft.com/office/drawing/2014/main" id="{133A2CB4-5002-D484-0EE4-408F2781E9BB}"/>
+                </a:ext>
+              </a:extLst>
+            </p:cNvPr>
+            <p:cNvGrpSpPr/>
+            <p:nvPr/>
+          </p:nvGrpSpPr>
+          <p:grpSpPr>
+            <a:xfrm>
+              <a:off x="4216582" y="3540112"/>
+              <a:ext cx="3758851" cy="2072521"/>
+              <a:chOff x="811462" y="1307911"/>
+              <a:chExt cx="3758851" cy="2072521"/>
+            </a:xfrm>
+          </p:grpSpPr>
+          <p:grpSp>
+            <p:nvGrpSpPr>
+              <p:cNvPr id="30" name="Grupo 29">
+                <a:extLst>
+                  <a:ext uri="{FF2B5EF4-FFF2-40B4-BE49-F238E27FC236}">
+                    <a16:creationId xmlns:a16="http://schemas.microsoft.com/office/drawing/2014/main" id="{18E5C1D7-8FCD-3428-8BF3-9A74712883DA}"/>
+                  </a:ext>
+                </a:extLst>
+              </p:cNvPr>
+              <p:cNvGrpSpPr/>
+              <p:nvPr/>
+            </p:nvGrpSpPr>
+            <p:grpSpPr>
+              <a:xfrm>
+                <a:off x="2288562" y="1307911"/>
+                <a:ext cx="804605" cy="882387"/>
+                <a:chOff x="2100116" y="1161875"/>
+                <a:chExt cx="1070929" cy="1174458"/>
+              </a:xfrm>
+            </p:grpSpPr>
+            <p:sp>
+              <p:nvSpPr>
+                <p:cNvPr id="39" name="Rectángulo 38">
+                  <a:extLst>
+                    <a:ext uri="{FF2B5EF4-FFF2-40B4-BE49-F238E27FC236}">
+                      <a16:creationId xmlns:a16="http://schemas.microsoft.com/office/drawing/2014/main" id="{0E9489EA-68F6-32EE-E16D-4AA1A35360BA}"/>
+                    </a:ext>
+                  </a:extLst>
+                </p:cNvPr>
+                <p:cNvSpPr/>
+                <p:nvPr/>
+              </p:nvSpPr>
+              <p:spPr>
+                <a:xfrm>
+                  <a:off x="2336341" y="1161875"/>
+                  <a:ext cx="834704" cy="1174458"/>
+                </a:xfrm>
+                <a:prstGeom prst="rect">
+                  <a:avLst/>
+                </a:prstGeom>
+                <a:solidFill>
+                  <a:schemeClr val="bg2">
+                    <a:lumMod val="90000"/>
+                  </a:schemeClr>
+                </a:solidFill>
+              </p:spPr>
+              <p:style>
+                <a:lnRef idx="2">
+                  <a:schemeClr val="accent1">
+                    <a:shade val="15000"/>
+                  </a:schemeClr>
+                </a:lnRef>
+                <a:fillRef idx="1">
+                  <a:schemeClr val="accent1"/>
+                </a:fillRef>
+                <a:effectRef idx="0">
+                  <a:schemeClr val="accent1"/>
+                </a:effectRef>
+                <a:fontRef idx="minor">
+                  <a:schemeClr val="lt1"/>
+                </a:fontRef>
+              </p:style>
+              <p:txBody>
+                <a:bodyPr rtlCol="0" anchor="ctr"/>
+                <a:lstStyle/>
+                <a:p>
+                  <a:pPr algn="ctr"/>
+                  <a:endParaRPr lang="es-ES"/>
+                </a:p>
+              </p:txBody>
+            </p:sp>
+            <p:sp>
+              <p:nvSpPr>
+                <p:cNvPr id="40" name="Elipse 39">
+                  <a:extLst>
+                    <a:ext uri="{FF2B5EF4-FFF2-40B4-BE49-F238E27FC236}">
+                      <a16:creationId xmlns:a16="http://schemas.microsoft.com/office/drawing/2014/main" id="{049C6249-890F-6A4B-0144-8C9D88688992}"/>
+                    </a:ext>
+                  </a:extLst>
+                </p:cNvPr>
+                <p:cNvSpPr/>
+                <p:nvPr/>
+              </p:nvSpPr>
+              <p:spPr>
+                <a:xfrm>
+                  <a:off x="2100116" y="1305718"/>
+                  <a:ext cx="644427" cy="211459"/>
+                </a:xfrm>
+                <a:prstGeom prst="ellipse">
+                  <a:avLst/>
+                </a:prstGeom>
+                <a:solidFill>
+                  <a:schemeClr val="bg1"/>
+                </a:solidFill>
+              </p:spPr>
+              <p:style>
+                <a:lnRef idx="2">
+                  <a:schemeClr val="accent1">
+                    <a:shade val="15000"/>
+                  </a:schemeClr>
+                </a:lnRef>
+                <a:fillRef idx="1">
+                  <a:schemeClr val="accent1"/>
+                </a:fillRef>
+                <a:effectRef idx="0">
+                  <a:schemeClr val="accent1"/>
+                </a:effectRef>
+                <a:fontRef idx="minor">
+                  <a:schemeClr val="lt1"/>
+                </a:fontRef>
+              </p:style>
+              <p:txBody>
+                <a:bodyPr rtlCol="0" anchor="ctr"/>
+                <a:lstStyle/>
+                <a:p>
+                  <a:pPr algn="ctr"/>
+                  <a:endParaRPr lang="es-ES"/>
+                </a:p>
+              </p:txBody>
+            </p:sp>
+            <p:sp>
+              <p:nvSpPr>
+                <p:cNvPr id="42" name="Rectángulo 41">
+                  <a:extLst>
+                    <a:ext uri="{FF2B5EF4-FFF2-40B4-BE49-F238E27FC236}">
+                      <a16:creationId xmlns:a16="http://schemas.microsoft.com/office/drawing/2014/main" id="{324F74EB-7ADA-AD10-635F-157EB082047B}"/>
+                    </a:ext>
+                  </a:extLst>
+                </p:cNvPr>
+                <p:cNvSpPr/>
+                <p:nvPr/>
+              </p:nvSpPr>
+              <p:spPr>
+                <a:xfrm>
+                  <a:off x="2100116" y="1639180"/>
+                  <a:ext cx="644427" cy="211459"/>
+                </a:xfrm>
+                <a:prstGeom prst="rect">
+                  <a:avLst/>
+                </a:prstGeom>
+                <a:solidFill>
+                  <a:schemeClr val="bg1"/>
+                </a:solidFill>
+              </p:spPr>
+              <p:style>
+                <a:lnRef idx="2">
+                  <a:schemeClr val="accent1">
+                    <a:shade val="15000"/>
+                  </a:schemeClr>
+                </a:lnRef>
+                <a:fillRef idx="1">
+                  <a:schemeClr val="accent1"/>
+                </a:fillRef>
+                <a:effectRef idx="0">
+                  <a:schemeClr val="accent1"/>
+                </a:effectRef>
+                <a:fontRef idx="minor">
+                  <a:schemeClr val="lt1"/>
+                </a:fontRef>
+              </p:style>
+              <p:txBody>
+                <a:bodyPr rtlCol="0" anchor="ctr"/>
+                <a:lstStyle/>
+                <a:p>
+                  <a:pPr algn="ctr"/>
+                  <a:endParaRPr lang="es-ES"/>
+                </a:p>
+              </p:txBody>
+            </p:sp>
+            <p:sp>
+              <p:nvSpPr>
+                <p:cNvPr id="43" name="Rectángulo 42">
+                  <a:extLst>
+                    <a:ext uri="{FF2B5EF4-FFF2-40B4-BE49-F238E27FC236}">
+                      <a16:creationId xmlns:a16="http://schemas.microsoft.com/office/drawing/2014/main" id="{1DA2D820-4EAA-4831-4D46-8842579F86FC}"/>
+                    </a:ext>
+                  </a:extLst>
+                </p:cNvPr>
+                <p:cNvSpPr/>
+                <p:nvPr/>
+              </p:nvSpPr>
+              <p:spPr>
+                <a:xfrm>
+                  <a:off x="2100116" y="1972642"/>
+                  <a:ext cx="644427" cy="211459"/>
+                </a:xfrm>
+                <a:prstGeom prst="rect">
+                  <a:avLst/>
+                </a:prstGeom>
+                <a:solidFill>
+                  <a:schemeClr val="bg1"/>
+                </a:solidFill>
+              </p:spPr>
+              <p:style>
+                <a:lnRef idx="2">
+                  <a:schemeClr val="accent1">
+                    <a:shade val="15000"/>
+                  </a:schemeClr>
+                </a:lnRef>
+                <a:fillRef idx="1">
+                  <a:schemeClr val="accent1"/>
+                </a:fillRef>
+                <a:effectRef idx="0">
+                  <a:schemeClr val="accent1"/>
+                </a:effectRef>
+                <a:fontRef idx="minor">
+                  <a:schemeClr val="lt1"/>
+                </a:fontRef>
+              </p:style>
+              <p:txBody>
+                <a:bodyPr rtlCol="0" anchor="ctr"/>
+                <a:lstStyle/>
+                <a:p>
+                  <a:pPr algn="ctr"/>
+                  <a:endParaRPr lang="es-ES"/>
+                </a:p>
+              </p:txBody>
+            </p:sp>
+          </p:grpSp>
+          <p:sp>
+            <p:nvSpPr>
+              <p:cNvPr id="38" name="CuadroTexto 37">
+                <a:extLst>
+                  <a:ext uri="{FF2B5EF4-FFF2-40B4-BE49-F238E27FC236}">
+                    <a16:creationId xmlns:a16="http://schemas.microsoft.com/office/drawing/2014/main" id="{AE43DAA6-324A-0394-3056-2A2EAB0D1BCB}"/>
+                  </a:ext>
+                </a:extLst>
+              </p:cNvPr>
+              <p:cNvSpPr txBox="1"/>
+              <p:nvPr/>
+            </p:nvSpPr>
+            <p:spPr>
+              <a:xfrm>
+                <a:off x="811462" y="2210881"/>
+                <a:ext cx="3758851" cy="1169551"/>
+              </a:xfrm>
+              <a:prstGeom prst="rect">
+                <a:avLst/>
+              </a:prstGeom>
+              <a:noFill/>
+            </p:spPr>
+            <p:txBody>
+              <a:bodyPr wrap="none" rtlCol="0">
+                <a:spAutoFit/>
+              </a:bodyPr>
+              <a:lstStyle/>
+              <a:p>
+                <a:pPr algn="ctr"/>
+                <a:r>
+                  <a:rPr lang="es-ES" sz="1400" dirty="0"/>
+                  <a:t>&lt;perfil&gt;/i18n/&lt;idioma&gt;/archetypes_labels.xml</a:t>
+                </a:r>
+              </a:p>
+              <a:p>
+                <a:pPr algn="ctr"/>
+                <a:r>
+                  <a:rPr lang="es-ES" sz="1400" dirty="0"/>
+                  <a:t>&lt;perfil&gt;/i18n/&lt;idioma&gt;/xslt_labels.xml</a:t>
+                </a:r>
+              </a:p>
+              <a:p>
+                <a:pPr algn="ctr"/>
+                <a:endParaRPr lang="es-ES" sz="1400" dirty="0"/>
+              </a:p>
+              <a:p>
+                <a:pPr algn="ctr"/>
+                <a:r>
+                  <a:rPr lang="es-ES" sz="1400" dirty="0"/>
+                  <a:t>Se accede desde XSLT mediante</a:t>
+                </a:r>
+              </a:p>
+              <a:p>
+                <a:pPr algn="ctr"/>
+                <a:r>
+                  <a:rPr lang="es-ES" sz="1400" b="1" dirty="0"/>
+                  <a:t>proteus-utils:i18n(</a:t>
+                </a:r>
+                <a:r>
+                  <a:rPr lang="es-ES" sz="1400" b="1" dirty="0" err="1"/>
+                  <a:t>key</a:t>
+                </a:r>
+                <a:r>
+                  <a:rPr lang="es-ES" sz="1400" b="1" dirty="0"/>
+                  <a:t>, ...)</a:t>
+                </a:r>
+              </a:p>
+            </p:txBody>
+          </p:sp>
+        </p:grpSp>
+      </p:grpSp>
+      <p:grpSp>
+        <p:nvGrpSpPr>
+          <p:cNvPr id="68" name="Grupo 67">
+            <a:extLst>
+              <a:ext uri="{FF2B5EF4-FFF2-40B4-BE49-F238E27FC236}">
+                <a16:creationId xmlns:a16="http://schemas.microsoft.com/office/drawing/2014/main" id="{A556FE39-E36C-3468-D1D0-8FD5087BC890}"/>
+              </a:ext>
+            </a:extLst>
+          </p:cNvPr>
+          <p:cNvGrpSpPr/>
+          <p:nvPr/>
+        </p:nvGrpSpPr>
+        <p:grpSpPr>
+          <a:xfrm>
+            <a:off x="8900767" y="2109665"/>
+            <a:ext cx="1761430" cy="571873"/>
+            <a:chOff x="6559262" y="455318"/>
+            <a:chExt cx="1761430" cy="571873"/>
+          </a:xfrm>
+        </p:grpSpPr>
+        <p:cxnSp>
+          <p:nvCxnSpPr>
+            <p:cNvPr id="26" name="Conector recto de flecha 25">
+              <a:extLst>
+                <a:ext uri="{FF2B5EF4-FFF2-40B4-BE49-F238E27FC236}">
+                  <a16:creationId xmlns:a16="http://schemas.microsoft.com/office/drawing/2014/main" id="{9C2A3544-575F-4C7E-2639-9CD3B553FB8E}"/>
+                </a:ext>
+              </a:extLst>
+            </p:cNvPr>
+            <p:cNvCxnSpPr>
+              <a:cxnSpLocks/>
+              <a:stCxn id="21" idx="2"/>
+              <a:endCxn id="75" idx="0"/>
+            </p:cNvCxnSpPr>
+            <p:nvPr/>
+          </p:nvCxnSpPr>
+          <p:spPr>
+            <a:xfrm>
+              <a:off x="6559262" y="455318"/>
+              <a:ext cx="1761430" cy="571873"/>
+            </a:xfrm>
+            <a:prstGeom prst="straightConnector1">
+              <a:avLst/>
+            </a:prstGeom>
+            <a:ln>
+              <a:solidFill>
+                <a:schemeClr val="tx1">
+                  <a:lumMod val="65000"/>
+                  <a:lumOff val="35000"/>
+                </a:schemeClr>
+              </a:solidFill>
+              <a:prstDash val="solid"/>
+              <a:tailEnd type="triangle" w="lg" len="lg"/>
+            </a:ln>
+          </p:spPr>
+          <p:style>
+            <a:lnRef idx="2">
+              <a:schemeClr val="accent1"/>
+            </a:lnRef>
+            <a:fillRef idx="0">
+              <a:schemeClr val="accent1"/>
+            </a:fillRef>
+            <a:effectRef idx="1">
+              <a:schemeClr val="accent1"/>
+            </a:effectRef>
+            <a:fontRef idx="minor">
+              <a:schemeClr val="tx1"/>
+            </a:fontRef>
+          </p:style>
+        </p:cxnSp>
+        <p:sp>
+          <p:nvSpPr>
+            <p:cNvPr id="67" name="CuadroTexto 66">
+              <a:extLst>
+                <a:ext uri="{FF2B5EF4-FFF2-40B4-BE49-F238E27FC236}">
+                  <a16:creationId xmlns:a16="http://schemas.microsoft.com/office/drawing/2014/main" id="{C2E214D1-DD2C-AEDF-C4C1-84AA0414140E}"/>
+                </a:ext>
+              </a:extLst>
+            </p:cNvPr>
+            <p:cNvSpPr txBox="1"/>
+            <p:nvPr/>
+          </p:nvSpPr>
+          <p:spPr>
+            <a:xfrm rot="1070032">
+              <a:off x="7169556" y="493809"/>
+              <a:ext cx="1032655" cy="276999"/>
+            </a:xfrm>
+            <a:prstGeom prst="rect">
+              <a:avLst/>
+            </a:prstGeom>
+            <a:noFill/>
+          </p:spPr>
+          <p:txBody>
+            <a:bodyPr wrap="none" rtlCol="0">
+              <a:spAutoFit/>
+            </a:bodyPr>
+            <a:lstStyle/>
+            <a:p>
+              <a:r>
+                <a:rPr lang="es-ES" sz="1200" dirty="0"/>
+                <a:t>«</a:t>
+              </a:r>
+              <a:r>
+                <a:rPr lang="es-ES" sz="1200" dirty="0" err="1"/>
+                <a:t>includes</a:t>
+              </a:r>
+              <a:r>
+                <a:rPr lang="es-ES" sz="1200" dirty="0"/>
+                <a:t>» ②</a:t>
+              </a:r>
+            </a:p>
+          </p:txBody>
+        </p:sp>
+      </p:grpSp>
+      <p:sp>
+        <p:nvSpPr>
+          <p:cNvPr id="72" name="Abrir llave 71">
+            <a:extLst>
+              <a:ext uri="{FF2B5EF4-FFF2-40B4-BE49-F238E27FC236}">
+                <a16:creationId xmlns:a16="http://schemas.microsoft.com/office/drawing/2014/main" id="{222AB1E0-62E7-D93F-BA3A-CDF668E85FEB}"/>
+              </a:ext>
+            </a:extLst>
+          </p:cNvPr>
+          <p:cNvSpPr/>
+          <p:nvPr/>
+        </p:nvSpPr>
+        <p:spPr>
+          <a:xfrm>
+            <a:off x="6081265" y="2453098"/>
+            <a:ext cx="227591" cy="4201645"/>
+          </a:xfrm>
+          <a:prstGeom prst="leftBrace">
+            <a:avLst/>
+          </a:prstGeom>
+          <a:ln>
+            <a:solidFill>
+              <a:schemeClr val="tx1">
+                <a:lumMod val="65000"/>
+                <a:lumOff val="35000"/>
+              </a:schemeClr>
+            </a:solidFill>
+          </a:ln>
+        </p:spPr>
+        <p:style>
+          <a:lnRef idx="2">
+            <a:schemeClr val="accent1"/>
+          </a:lnRef>
+          <a:fillRef idx="0">
+            <a:schemeClr val="accent1"/>
+          </a:fillRef>
+          <a:effectRef idx="1">
+            <a:schemeClr val="accent1"/>
+          </a:effectRef>
+          <a:fontRef idx="minor">
+            <a:schemeClr val="tx1"/>
+          </a:fontRef>
+        </p:style>
+        <p:txBody>
+          <a:bodyPr rtlCol="0" anchor="ctr"/>
+          <a:lstStyle/>
+          <a:p>
+            <a:pPr algn="ctr"/>
+            <a:endParaRPr lang="es-ES"/>
+          </a:p>
+        </p:txBody>
+      </p:sp>
+    </p:spTree>
+    <p:extLst>
+      <p:ext uri="{BB962C8B-B14F-4D97-AF65-F5344CB8AC3E}">
+        <p14:creationId xmlns:p14="http://schemas.microsoft.com/office/powerpoint/2010/main" val="3163924095"/>
+      </p:ext>
+    </p:extLst>
+  </p:cSld>
+  <p:clrMapOvr>
+    <a:masterClrMapping/>
+  </p:clrMapOvr>
+</p:sld>
+</file>
+
+<file path=ppt/slides/slide5.xml><?xml version="1.0" encoding="utf-8"?>
+<p:sld xmlns:a="http://schemas.openxmlformats.org/drawingml/2006/main" xmlns:r="http://schemas.openxmlformats.org/officeDocument/2006/relationships" xmlns:p="http://schemas.openxmlformats.org/presentationml/2006/main">
+  <p:cSld>
+    <p:spTree>
+      <p:nvGrpSpPr>
         <p:cNvPr id="1" name=""/>
         <p:cNvGrpSpPr/>
         <p:nvPr/>
@@ -11149,7 +13342,7 @@
 </p:sld>
 </file>
 
-<file path=ppt/slides/slide5.xml><?xml version="1.0" encoding="utf-8"?>
+<file path=ppt/slides/slide6.xml><?xml version="1.0" encoding="utf-8"?>
 <p:sld xmlns:a="http://schemas.openxmlformats.org/drawingml/2006/main" xmlns:r="http://schemas.openxmlformats.org/officeDocument/2006/relationships" xmlns:p="http://schemas.openxmlformats.org/presentationml/2006/main">
   <p:cSld>
     <p:spTree>

</xml_diff>

<commit_message>
Added a new property exclusion mechanism to the XSLT transformation for generating tables. The previous implementation only considered a single list of excluded properties, which could lead to partial matches and unintended exclusions. The updated code now wraps both the list of excluded properties and the current property name with commas, ensuring that only whole names are matched. This change was suggested by Claude AI to improve the accuracy of property filtering during table generation.
</commit_message>
<xml_diff>
--- a/documentation/Refactorización XLST.pptx
+++ b/documentation/Refactorización XLST.pptx
@@ -10,7 +10,8 @@
     <p:sldId id="259" r:id="rId4"/>
     <p:sldId id="262" r:id="rId5"/>
     <p:sldId id="260" r:id="rId6"/>
-    <p:sldId id="261" r:id="rId7"/>
+    <p:sldId id="263" r:id="rId7"/>
+    <p:sldId id="261" r:id="rId8"/>
   </p:sldIdLst>
   <p:sldSz cx="12192000" cy="6858000"/>
   <p:notesSz cx="6797675" cy="9926638"/>
@@ -829,7 +830,7 @@
           <a:p>
             <a:fld id="{93065D2E-367D-4F9D-9E24-4F44260CE426}" type="datetimeFigureOut">
               <a:rPr lang="es-ES" smtClean="0"/>
-              <a:t>17/09/2026</a:t>
+              <a:t>20/09/2026</a:t>
             </a:fld>
             <a:endParaRPr lang="es-ES"/>
           </a:p>
@@ -1027,7 +1028,7 @@
           <a:p>
             <a:fld id="{93065D2E-367D-4F9D-9E24-4F44260CE426}" type="datetimeFigureOut">
               <a:rPr lang="es-ES" smtClean="0"/>
-              <a:t>17/09/2026</a:t>
+              <a:t>20/09/2026</a:t>
             </a:fld>
             <a:endParaRPr lang="es-ES"/>
           </a:p>
@@ -1235,7 +1236,7 @@
           <a:p>
             <a:fld id="{93065D2E-367D-4F9D-9E24-4F44260CE426}" type="datetimeFigureOut">
               <a:rPr lang="es-ES" smtClean="0"/>
-              <a:t>17/09/2026</a:t>
+              <a:t>20/09/2026</a:t>
             </a:fld>
             <a:endParaRPr lang="es-ES"/>
           </a:p>
@@ -1433,7 +1434,7 @@
           <a:p>
             <a:fld id="{93065D2E-367D-4F9D-9E24-4F44260CE426}" type="datetimeFigureOut">
               <a:rPr lang="es-ES" smtClean="0"/>
-              <a:t>17/09/2026</a:t>
+              <a:t>20/09/2026</a:t>
             </a:fld>
             <a:endParaRPr lang="es-ES"/>
           </a:p>
@@ -1708,7 +1709,7 @@
           <a:p>
             <a:fld id="{93065D2E-367D-4F9D-9E24-4F44260CE426}" type="datetimeFigureOut">
               <a:rPr lang="es-ES" smtClean="0"/>
-              <a:t>17/09/2026</a:t>
+              <a:t>20/09/2026</a:t>
             </a:fld>
             <a:endParaRPr lang="es-ES"/>
           </a:p>
@@ -1973,7 +1974,7 @@
           <a:p>
             <a:fld id="{93065D2E-367D-4F9D-9E24-4F44260CE426}" type="datetimeFigureOut">
               <a:rPr lang="es-ES" smtClean="0"/>
-              <a:t>17/09/2026</a:t>
+              <a:t>20/09/2026</a:t>
             </a:fld>
             <a:endParaRPr lang="es-ES"/>
           </a:p>
@@ -2385,7 +2386,7 @@
           <a:p>
             <a:fld id="{93065D2E-367D-4F9D-9E24-4F44260CE426}" type="datetimeFigureOut">
               <a:rPr lang="es-ES" smtClean="0"/>
-              <a:t>17/09/2026</a:t>
+              <a:t>20/09/2026</a:t>
             </a:fld>
             <a:endParaRPr lang="es-ES"/>
           </a:p>
@@ -2526,7 +2527,7 @@
           <a:p>
             <a:fld id="{93065D2E-367D-4F9D-9E24-4F44260CE426}" type="datetimeFigureOut">
               <a:rPr lang="es-ES" smtClean="0"/>
-              <a:t>17/09/2026</a:t>
+              <a:t>20/09/2026</a:t>
             </a:fld>
             <a:endParaRPr lang="es-ES"/>
           </a:p>
@@ -2639,7 +2640,7 @@
           <a:p>
             <a:fld id="{93065D2E-367D-4F9D-9E24-4F44260CE426}" type="datetimeFigureOut">
               <a:rPr lang="es-ES" smtClean="0"/>
-              <a:t>17/09/2026</a:t>
+              <a:t>20/09/2026</a:t>
             </a:fld>
             <a:endParaRPr lang="es-ES"/>
           </a:p>
@@ -2950,7 +2951,7 @@
           <a:p>
             <a:fld id="{93065D2E-367D-4F9D-9E24-4F44260CE426}" type="datetimeFigureOut">
               <a:rPr lang="es-ES" smtClean="0"/>
-              <a:t>17/09/2026</a:t>
+              <a:t>20/09/2026</a:t>
             </a:fld>
             <a:endParaRPr lang="es-ES"/>
           </a:p>
@@ -3238,7 +3239,7 @@
           <a:p>
             <a:fld id="{93065D2E-367D-4F9D-9E24-4F44260CE426}" type="datetimeFigureOut">
               <a:rPr lang="es-ES" smtClean="0"/>
-              <a:t>17/09/2026</a:t>
+              <a:t>20/09/2026</a:t>
             </a:fld>
             <a:endParaRPr lang="es-ES"/>
           </a:p>
@@ -3479,7 +3480,7 @@
           <a:p>
             <a:fld id="{93065D2E-367D-4F9D-9E24-4F44260CE426}" type="datetimeFigureOut">
               <a:rPr lang="es-ES" smtClean="0"/>
-              <a:t>17/09/2026</a:t>
+              <a:t>20/09/2026</a:t>
             </a:fld>
             <a:endParaRPr lang="es-ES"/>
           </a:p>
@@ -13347,6 +13348,72 @@
   <p:cSld>
     <p:spTree>
       <p:nvGrpSpPr>
+        <p:cNvPr id="1" name="">
+          <a:extLst>
+            <a:ext uri="{FF2B5EF4-FFF2-40B4-BE49-F238E27FC236}">
+              <a16:creationId xmlns:a16="http://schemas.microsoft.com/office/drawing/2014/main" id="{9F1630CE-D883-96C3-C3F5-AD72995000EA}"/>
+            </a:ext>
+          </a:extLst>
+        </p:cNvPr>
+        <p:cNvGrpSpPr/>
+        <p:nvPr/>
+      </p:nvGrpSpPr>
+      <p:grpSpPr>
+        <a:xfrm>
+          <a:off x="0" y="0"/>
+          <a:ext cx="0" cy="0"/>
+          <a:chOff x="0" y="0"/>
+          <a:chExt cx="0" cy="0"/>
+        </a:xfrm>
+      </p:grpSpPr>
+      <p:pic>
+        <p:nvPicPr>
+          <p:cNvPr id="8" name="Imagen 7">
+            <a:extLst>
+              <a:ext uri="{FF2B5EF4-FFF2-40B4-BE49-F238E27FC236}">
+                <a16:creationId xmlns:a16="http://schemas.microsoft.com/office/drawing/2014/main" id="{442E89C4-8430-BD5D-7505-B26A2E74E936}"/>
+              </a:ext>
+            </a:extLst>
+          </p:cNvPr>
+          <p:cNvPicPr>
+            <a:picLocks noChangeAspect="1"/>
+          </p:cNvPicPr>
+          <p:nvPr/>
+        </p:nvPicPr>
+        <p:blipFill>
+          <a:blip r:embed="rId2"/>
+          <a:stretch>
+            <a:fillRect/>
+          </a:stretch>
+        </p:blipFill>
+        <p:spPr>
+          <a:xfrm>
+            <a:off x="987259" y="1002218"/>
+            <a:ext cx="6925642" cy="1619476"/>
+          </a:xfrm>
+          <a:prstGeom prst="rect">
+            <a:avLst/>
+          </a:prstGeom>
+        </p:spPr>
+      </p:pic>
+    </p:spTree>
+    <p:extLst>
+      <p:ext uri="{BB962C8B-B14F-4D97-AF65-F5344CB8AC3E}">
+        <p14:creationId xmlns:p14="http://schemas.microsoft.com/office/powerpoint/2010/main" val="4122364074"/>
+      </p:ext>
+    </p:extLst>
+  </p:cSld>
+  <p:clrMapOvr>
+    <a:masterClrMapping/>
+  </p:clrMapOvr>
+</p:sld>
+</file>
+
+<file path=ppt/slides/slide7.xml><?xml version="1.0" encoding="utf-8"?>
+<p:sld xmlns:a="http://schemas.openxmlformats.org/drawingml/2006/main" xmlns:r="http://schemas.openxmlformats.org/officeDocument/2006/relationships" xmlns:p="http://schemas.openxmlformats.org/presentationml/2006/main">
+  <p:cSld>
+    <p:spTree>
+      <p:nvGrpSpPr>
         <p:cNvPr id="1" name=""/>
         <p:cNvGrpSpPr/>
         <p:nvPr/>

</xml_diff>